<commit_message>
Refresh the review deck and finish the folder cleanup
</commit_message>
<xml_diff>
--- a/docs/a2/review-slides-simplified.pptx
+++ b/docs/a2/review-slides-simplified.pptx
@@ -2,18 +2,18 @@
 <file path=ppt/presentation.xml><?xml version="1.0" encoding="utf-8"?>
 <p:presentation xmlns:p="http://schemas.openxmlformats.org/presentationml/2006/main">
   <p:sldMasterIdLst>
-    <p:sldMasterId xmlns:r="http://schemas.openxmlformats.org/officeDocument/2006/relationships" id="2147483648" r:id="Rc30bd744a3324e14"/>
+    <p:sldMasterId xmlns:r="http://schemas.openxmlformats.org/officeDocument/2006/relationships" id="2147483648" r:id="R75e052afee904b91"/>
   </p:sldMasterIdLst>
   <p:notesMasterIdLst>
-    <p:notesMasterId xmlns:r="http://schemas.openxmlformats.org/officeDocument/2006/relationships" r:id="Rc40326d9dca1447c"/>
+    <p:notesMasterId xmlns:r="http://schemas.openxmlformats.org/officeDocument/2006/relationships" r:id="R4ef18e7829d54b48"/>
   </p:notesMasterIdLst>
   <p:sldIdLst>
-    <p:sldId xmlns:r="http://schemas.openxmlformats.org/officeDocument/2006/relationships" id="256" r:id="R545fa3e787674208"/>
-    <p:sldId xmlns:r="http://schemas.openxmlformats.org/officeDocument/2006/relationships" id="257" r:id="R8390f68e1eea427d"/>
-    <p:sldId xmlns:r="http://schemas.openxmlformats.org/officeDocument/2006/relationships" id="258" r:id="R369aa28e37244351"/>
-    <p:sldId xmlns:r="http://schemas.openxmlformats.org/officeDocument/2006/relationships" id="259" r:id="R3c0e727ef30349a5"/>
-    <p:sldId xmlns:r="http://schemas.openxmlformats.org/officeDocument/2006/relationships" id="260" r:id="Ra2433104f4584f8c"/>
-    <p:sldId xmlns:r="http://schemas.openxmlformats.org/officeDocument/2006/relationships" id="261" r:id="R88d58e4888a94ccd"/>
+    <p:sldId xmlns:r="http://schemas.openxmlformats.org/officeDocument/2006/relationships" id="256" r:id="R648f395b66224787"/>
+    <p:sldId xmlns:r="http://schemas.openxmlformats.org/officeDocument/2006/relationships" id="257" r:id="Reb6c063538274ee6"/>
+    <p:sldId xmlns:r="http://schemas.openxmlformats.org/officeDocument/2006/relationships" id="258" r:id="Rc2caa89bd6ae4414"/>
+    <p:sldId xmlns:r="http://schemas.openxmlformats.org/officeDocument/2006/relationships" id="259" r:id="Rce11a347c7774683"/>
+    <p:sldId xmlns:r="http://schemas.openxmlformats.org/officeDocument/2006/relationships" id="260" r:id="R39587b10b86f420d"/>
+    <p:sldId xmlns:r="http://schemas.openxmlformats.org/officeDocument/2006/relationships" id="261" r:id="R7d2e9d4943b44c96"/>
   </p:sldIdLst>
   <p:sldSz cx="12192000" cy="6858000"/>
   <p:notesSz cx="6858000" cy="9144000"/>
@@ -163,9 +163,9 @@
 </file>
 
 <file path=ppt/notesMasters/theme/theme3.xml><?xml version="1.0" encoding="utf-8"?>
-<a:theme xmlns:a="http://schemas.openxmlformats.org/drawingml/2006/main" name="ChatGPT">
+<a:theme xmlns:a="http://schemas.openxmlformats.org/drawingml/2006/main" name="ECOllateral">
   <a:themeElements>
-    <a:clrScheme name="ChatGPT">
+    <a:clrScheme name="ECOllateral">
       <a:dk1>
         <a:srgbClr val="000000"/>
       </a:dk1>
@@ -215,7 +215,7 @@
         <a:cs typeface="Calibri"/>
       </a:minorFont>
     </a:fontScheme>
-    <a:fmtScheme name="ChatGPT">
+    <a:fmtScheme name="ECOllateral">
       <a:fillStyleLst>
         <a:solidFill>
           <a:schemeClr val="phClr"/>
@@ -467,12 +467,17 @@
           </a:p>
           <a:p xmlns:a="http://schemas.openxmlformats.org/drawingml/2006/main">
             <a:r>
-              <a:t>Cooling is one example. We still need area water totals and river needs. The AI learns</a:t>
-            </a:r>
-          </a:p>
-          <a:p xmlns:a="http://schemas.openxmlformats.org/drawingml/2006/main">
-            <a:r>
-              <a:t>made-up water-use values, so real area tests are still needed.</a:t>
+              <a:t>Cooling is one example. Current tests use computer-generated water-use examples to</a:t>
+            </a:r>
+          </a:p>
+          <a:p xmlns:a="http://schemas.openxmlformats.org/drawingml/2006/main">
+            <a:r>
+              <a:t>check the software. Next, collect real measurements, train on them, and test on records</a:t>
+            </a:r>
+          </a:p>
+          <a:p xmlns:a="http://schemas.openxmlformats.org/drawingml/2006/main">
+            <a:r>
+              <a:t>the model has not seen. We still need area water totals and river needs.</a:t>
             </a:r>
           </a:p>
           <a:p xmlns:a="http://schemas.openxmlformats.org/drawingml/2006/main">
@@ -487,12 +492,17 @@
           </a:p>
           <a:p xmlns:a="http://schemas.openxmlformats.org/drawingml/2006/main">
             <a:r>
-              <a:t>Shaun, 30 seconds. Source: docs/a2/dossier.md section 1; docs/a2/evidence/forecast.json. Synthetic labels and fictional permits. Public ingestion is a parser smoke test. The current collateral stress field is an on-site consumption proxy. Assigned day is pending.</a:t>
+              <a:t>Shaun, 30 seconds. Source: docs/a2/source/dossier.md section 1; docs/a2/evidence/forecast.json. Synthetic labels and fictional permits. Public ingestion is a parser smoke test. The current collateral stress field is an on-site consumption proxy. Assigned day is pending.</a:t>
             </a:r>
           </a:p>
           <a:p xmlns:a="http://schemas.openxmlformats.org/drawingml/2006/main">
             <a:r>
               <a:t>Regional framing: ECOllateral is an environmental impact assessment and regional ecosystem forecasting project. Primary question: development demands/cooling/location and seasonal impacts on area municipal reserves and watershed conditions. The cooling model is one pressure component. No regional impact or ecosystem health score is implemented/validated. Source: docs/project-scope.md and user context supplied October 8.</a:t>
+            </a:r>
+          </a:p>
+          <a:p xmlns:a="http://schemas.openxmlformats.org/drawingml/2006/main">
+            <a:r>
+              <a:t>Data plan: generated examples are current software checks. Collect paired measured inputs and outcomes, train on historical observations, and test on real records and areas excluded from training. No measured-target retraining has been completed.</a:t>
             </a:r>
           </a:p>
         </p:txBody>
@@ -717,7 +727,7 @@
           </a:p>
           <a:p xmlns:a="http://schemas.openxmlformats.org/drawingml/2006/main">
             <a:r>
-              <a:t>Next, we need real water-use and area measurements.</a:t>
+              <a:t>Next, train on real water-use measurements and test on separate real records.</a:t>
             </a:r>
           </a:p>
           <a:p xmlns:a="http://schemas.openxmlformats.org/drawingml/2006/main">
@@ -1057,7 +1067,12 @@
           </a:p>
           <a:p xmlns:a="http://schemas.openxmlformats.org/drawingml/2006/main">
             <a:r>
-              <a:t>show weaknesses. We must add water coming in, water used and returned, and river needs.</a:t>
+              <a:t>show weaknesses. Next, collect real measurements, train on them, and test new areas.</a:t>
+            </a:r>
+          </a:p>
+          <a:p xmlns:a="http://schemas.openxmlformats.org/drawingml/2006/main">
+            <a:r>
+              <a:t>We must add water coming in, water used and returned, and river needs.</a:t>
             </a:r>
           </a:p>
           <a:p xmlns:a="http://schemas.openxmlformats.org/drawingml/2006/main">
@@ -1087,7 +1102,12 @@
           </a:p>
           <a:p xmlns:a="http://schemas.openxmlformats.org/drawingml/2006/main">
             <a:r>
-              <a:t>can we test effects on water reserves and rivers in a new area through the year?</a:t>
+              <a:t>can training on real data predict effects on water reserves and rivers in a new area</a:t>
+            </a:r>
+          </a:p>
+          <a:p xmlns:a="http://schemas.openxmlformats.org/drawingml/2006/main">
+            <a:r>
+              <a:t>through the year?</a:t>
             </a:r>
           </a:p>
           <a:p xmlns:a="http://schemas.openxmlformats.org/drawingml/2006/main">
@@ -1102,12 +1122,17 @@
           </a:p>
           <a:p xmlns:a="http://schemas.openxmlformats.org/drawingml/2006/main">
             <a:r>
-              <a:t>Scott, 60 seconds. Source: docs/a2/dossier.md sections 7-8, evidence-summary.csv, team-contributions.md. No neural/LLM comparison run. Shaun majority coding is confirmed; Troy/Scott supporting responsibilities are assigned, not certified completed. Next measured-label study needs facility holdouts, verified station maps, real permit relevance, MAE/RMSE/R2/coverage/width. Course date, deadline, office hours and instructor access remain pending.</a:t>
+              <a:t>Scott, 60 seconds. Source: docs/a2/source/dossier.md sections 7-8, evidence-summary.csv, team-contributions.md. No neural/LLM comparison run. Shaun majority coding is confirmed; Troy/Scott supporting responsibilities are assigned, not certified completed. Next measured-label study needs facility holdouts, verified station maps, real permit relevance, MAE/RMSE/R2/coverage/width. Course date, deadline, office hours and instructor access remain pending.</a:t>
             </a:r>
           </a:p>
           <a:p xmlns:a="http://schemas.openxmlformats.org/drawingml/2006/main">
             <a:r>
               <a:t>Primary next study: observed regional supply/reserves, demands, returns, ecological baselines and unseen-area tests. Facility holdouts remain a supporting component check. Zero-shot LLM, heatwave validation, EIA/EPA ingestion and historical recharge masking are proposals, not completed benchmarks. Troy supports data/grounding; Scott evaluation/interface/failure evidence; Shaun leads coding.</a:t>
+            </a:r>
+          </a:p>
+          <a:p xmlns:a="http://schemas.openxmlformats.org/drawingml/2006/main">
+            <a:r>
+              <a:t>Real-data training is the next development step, not a completed result. Define area outcomes and river needs before claiming ecosystem forecasts. Keep model selection, interval sizing and final real-data testing separate.</a:t>
             </a:r>
           </a:p>
         </p:txBody>
@@ -1175,7 +1200,7 @@
   </p:cSld>
   <p:clrMap bg1="lt1" tx1="dk1" bg2="lt2" tx2="dk2" accent1="accent1" accent2="accent2" accent3="accent3" accent4="accent4" accent5="accent5" accent6="accent6" hlink="hlink" folHlink="folHlink"/>
   <p:sldLayoutIdLst>
-    <p:sldLayoutId xmlns:r="http://schemas.openxmlformats.org/officeDocument/2006/relationships" id="2147483649" r:id="R75eba4965b164cee"/>
+    <p:sldLayoutId xmlns:r="http://schemas.openxmlformats.org/officeDocument/2006/relationships" id="2147483649" r:id="R91986dd7aafe442a"/>
   </p:sldLayoutIdLst>
   <p:txStyles>
     <p:titleStyle>
@@ -1458,9 +1483,9 @@
 </file>
 
 <file path=ppt/slideMasters/theme/theme2.xml><?xml version="1.0" encoding="utf-8"?>
-<a:theme xmlns:a="http://schemas.openxmlformats.org/drawingml/2006/main" name="ChatGPT">
+<a:theme xmlns:a="http://schemas.openxmlformats.org/drawingml/2006/main" name="ECOllateral">
   <a:themeElements>
-    <a:clrScheme name="ChatGPT">
+    <a:clrScheme name="ECOllateral">
       <a:dk1>
         <a:srgbClr val="000000"/>
       </a:dk1>
@@ -1510,7 +1535,7 @@
         <a:cs typeface="Calibri"/>
       </a:minorFont>
     </a:fontScheme>
-    <a:fmtScheme name="ChatGPT">
+    <a:fmtScheme name="ECOllateral">
       <a:fillStyleLst>
         <a:solidFill>
           <a:schemeClr val="phClr"/>
@@ -2526,7 +2551,7 @@
           <p:cNvPr id="15" name="">
             <a:extLst xmlns:a="http://schemas.openxmlformats.org/drawingml/2006/main">
               <a:ext uri="{FF2B5EF4-FFF2-40B4-BE49-F238E27FC236}">
-                <a16:creationId xmlns:a16="http://schemas.microsoft.com/office/drawing/2014/main" id="{E15926F0-6E43-4A8D-9B42-CB96E57B38CF}"/>
+                <a16:creationId xmlns:a16="http://schemas.microsoft.com/office/drawing/2014/main" id="{2A06DBD1-C1C1-4778-A500-74D7B6B5D494}"/>
               </a:ext>
             </a:extLst>
           </p:cNvPr>
@@ -2583,7 +2608,7 @@
           <p:cNvPr id="2" name="">
             <a:extLst xmlns:a="http://schemas.openxmlformats.org/drawingml/2006/main">
               <a:ext uri="{FF2B5EF4-FFF2-40B4-BE49-F238E27FC236}">
-                <a16:creationId xmlns:a16="http://schemas.microsoft.com/office/drawing/2014/main" id="{BF72D7B3-7365-43ED-BC31-EE0F07A7AED1}"/>
+                <a16:creationId xmlns:a16="http://schemas.microsoft.com/office/drawing/2014/main" id="{782A956B-9858-45B7-B911-2C4E49B74605}"/>
               </a:ext>
             </a:extLst>
           </p:cNvPr>
@@ -2613,7 +2638,7 @@
           <p:cNvPr id="3" name="">
             <a:extLst xmlns:a="http://schemas.openxmlformats.org/drawingml/2006/main">
               <a:ext uri="{FF2B5EF4-FFF2-40B4-BE49-F238E27FC236}">
-                <a16:creationId xmlns:a16="http://schemas.microsoft.com/office/drawing/2014/main" id="{9D28E4F8-64DB-4E0D-85EA-D1161F382CCC}"/>
+                <a16:creationId xmlns:a16="http://schemas.microsoft.com/office/drawing/2014/main" id="{546B17B5-1825-4EF3-BB0E-C1919E61E351}"/>
               </a:ext>
             </a:extLst>
           </p:cNvPr>
@@ -2693,7 +2718,7 @@
           <p:cNvPr id="4" name="">
             <a:extLst xmlns:a="http://schemas.openxmlformats.org/drawingml/2006/main">
               <a:ext uri="{FF2B5EF4-FFF2-40B4-BE49-F238E27FC236}">
-                <a16:creationId xmlns:a16="http://schemas.microsoft.com/office/drawing/2014/main" id="{779038A3-1B39-4D8D-88A9-CD7240E68276}"/>
+                <a16:creationId xmlns:a16="http://schemas.microsoft.com/office/drawing/2014/main" id="{2F1C7964-98D2-4FF4-816A-C9992DBBE5AE}"/>
               </a:ext>
             </a:extLst>
           </p:cNvPr>
@@ -2740,7 +2765,7 @@
                 <a:ea typeface="Arial"/>
                 <a:cs typeface="Arial"/>
               </a:rPr>
-              <a:t>October 7 test results. Made-up water-use targets. Area impacts still need real-world tests.</a:t>
+              <a:t>Current tests use generated values. Next: train and test on real measurements.</a:t>
             </a:r>
           </a:p>
         </p:txBody>
@@ -2750,7 +2775,7 @@
           <p:cNvPr id="5" name="">
             <a:extLst xmlns:a="http://schemas.openxmlformats.org/drawingml/2006/main">
               <a:ext uri="{FF2B5EF4-FFF2-40B4-BE49-F238E27FC236}">
-                <a16:creationId xmlns:a16="http://schemas.microsoft.com/office/drawing/2014/main" id="{AE6CEA40-2B85-4395-906A-C543DBEC9910}"/>
+                <a16:creationId xmlns:a16="http://schemas.microsoft.com/office/drawing/2014/main" id="{750E40C1-4603-4AFA-802F-5C0091E374B4}"/>
               </a:ext>
             </a:extLst>
           </p:cNvPr>
@@ -2807,7 +2832,7 @@
           <p:cNvPr id="6" name="">
             <a:extLst xmlns:a="http://schemas.openxmlformats.org/drawingml/2006/main">
               <a:ext uri="{FF2B5EF4-FFF2-40B4-BE49-F238E27FC236}">
-                <a16:creationId xmlns:a16="http://schemas.microsoft.com/office/drawing/2014/main" id="{32C89695-524B-4344-8DA4-22B3EF26249D}"/>
+                <a16:creationId xmlns:a16="http://schemas.microsoft.com/office/drawing/2014/main" id="{643B33D5-FA2E-4382-BE9E-24324A594025}"/>
               </a:ext>
             </a:extLst>
           </p:cNvPr>
@@ -2864,7 +2889,7 @@
           <p:cNvPr id="7" name="">
             <a:extLst xmlns:a="http://schemas.openxmlformats.org/drawingml/2006/main">
               <a:ext uri="{FF2B5EF4-FFF2-40B4-BE49-F238E27FC236}">
-                <a16:creationId xmlns:a16="http://schemas.microsoft.com/office/drawing/2014/main" id="{93569346-F43C-484B-9806-56AC43118A2F}"/>
+                <a16:creationId xmlns:a16="http://schemas.microsoft.com/office/drawing/2014/main" id="{3061CC4A-D9A6-4979-8A02-788657C8F33E}"/>
               </a:ext>
             </a:extLst>
           </p:cNvPr>
@@ -2921,7 +2946,7 @@
           <p:cNvPr id="8" name="">
             <a:extLst xmlns:a="http://schemas.openxmlformats.org/drawingml/2006/main">
               <a:ext uri="{FF2B5EF4-FFF2-40B4-BE49-F238E27FC236}">
-                <a16:creationId xmlns:a16="http://schemas.microsoft.com/office/drawing/2014/main" id="{117F3970-3D92-419F-B65E-0F3E8509E11D}"/>
+                <a16:creationId xmlns:a16="http://schemas.microsoft.com/office/drawing/2014/main" id="{6F432F47-803A-4516-B075-24CA9DB778B8}"/>
               </a:ext>
             </a:extLst>
           </p:cNvPr>
@@ -2978,7 +3003,7 @@
           <p:cNvPr id="9" name="">
             <a:extLst xmlns:a="http://schemas.openxmlformats.org/drawingml/2006/main">
               <a:ext uri="{FF2B5EF4-FFF2-40B4-BE49-F238E27FC236}">
-                <a16:creationId xmlns:a16="http://schemas.microsoft.com/office/drawing/2014/main" id="{13257136-DEB8-46AB-80B8-0914AEE78659}"/>
+                <a16:creationId xmlns:a16="http://schemas.microsoft.com/office/drawing/2014/main" id="{E05FF779-983C-49B7-A1AD-A8CB5E8B2C64}"/>
               </a:ext>
             </a:extLst>
           </p:cNvPr>
@@ -3008,7 +3033,7 @@
           <p:cNvPr id="10" name="">
             <a:extLst xmlns:a="http://schemas.openxmlformats.org/drawingml/2006/main">
               <a:ext uri="{FF2B5EF4-FFF2-40B4-BE49-F238E27FC236}">
-                <a16:creationId xmlns:a16="http://schemas.microsoft.com/office/drawing/2014/main" id="{E1E03F3C-42F0-45FA-8463-6B96C68FBC6F}"/>
+                <a16:creationId xmlns:a16="http://schemas.microsoft.com/office/drawing/2014/main" id="{418D8BE0-AF0E-4273-B270-1EDD8DE52EE0}"/>
               </a:ext>
             </a:extLst>
           </p:cNvPr>
@@ -3111,7 +3136,7 @@
           <p:cNvPr id="11" name="">
             <a:extLst xmlns:a="http://schemas.openxmlformats.org/drawingml/2006/main">
               <a:ext uri="{FF2B5EF4-FFF2-40B4-BE49-F238E27FC236}">
-                <a16:creationId xmlns:a16="http://schemas.microsoft.com/office/drawing/2014/main" id="{64450D52-730F-4321-ABFA-C04F638B162D}"/>
+                <a16:creationId xmlns:a16="http://schemas.microsoft.com/office/drawing/2014/main" id="{63B5A434-D04D-4752-8DB1-AA4087EC46C2}"/>
               </a:ext>
             </a:extLst>
           </p:cNvPr>
@@ -3168,7 +3193,7 @@
           <p:cNvPr id="12" name="">
             <a:extLst xmlns:a="http://schemas.openxmlformats.org/drawingml/2006/main">
               <a:ext uri="{FF2B5EF4-FFF2-40B4-BE49-F238E27FC236}">
-                <a16:creationId xmlns:a16="http://schemas.microsoft.com/office/drawing/2014/main" id="{965D7732-E1E7-42B1-94F1-8AA949C38236}"/>
+                <a16:creationId xmlns:a16="http://schemas.microsoft.com/office/drawing/2014/main" id="{903E1B86-FB17-4961-9A70-A1C38D63D45A}"/>
               </a:ext>
             </a:extLst>
           </p:cNvPr>
@@ -3198,7 +3223,7 @@
           <p:cNvPr id="13" name="">
             <a:extLst xmlns:a="http://schemas.openxmlformats.org/drawingml/2006/main">
               <a:ext uri="{FF2B5EF4-FFF2-40B4-BE49-F238E27FC236}">
-                <a16:creationId xmlns:a16="http://schemas.microsoft.com/office/drawing/2014/main" id="{A41E9DB1-E81B-47FA-90E6-60A65547F825}"/>
+                <a16:creationId xmlns:a16="http://schemas.microsoft.com/office/drawing/2014/main" id="{61707A55-DCF3-46CC-9ACD-0AA9457649DA}"/>
               </a:ext>
             </a:extLst>
           </p:cNvPr>
@@ -3301,7 +3326,7 @@
           <p:cNvPr id="14" name="">
             <a:extLst xmlns:a="http://schemas.openxmlformats.org/drawingml/2006/main">
               <a:ext uri="{FF2B5EF4-FFF2-40B4-BE49-F238E27FC236}">
-                <a16:creationId xmlns:a16="http://schemas.microsoft.com/office/drawing/2014/main" id="{8D735B82-0085-4D4D-A641-4BAC5D26F490}"/>
+                <a16:creationId xmlns:a16="http://schemas.microsoft.com/office/drawing/2014/main" id="{D7AC6CAF-2F27-4C53-8A4A-FBA42666328A}"/>
               </a:ext>
             </a:extLst>
           </p:cNvPr>
@@ -3356,7 +3381,7 @@
     </p:spTree>
     <p:extLst>
       <p:ext uri="{BB962C8B-B14F-4D97-AF65-F5344CB8AC3E}">
-        <p14:creationId xmlns:p14="http://schemas.microsoft.com/office/powerpoint/2010/main" val="2078059179"/>
+        <p14:creationId xmlns:p14="http://schemas.microsoft.com/office/powerpoint/2010/main" val="1250705555"/>
       </p:ext>
     </p:extLst>
   </p:cSld>
@@ -3387,7 +3412,7 @@
           <p:cNvPr id="58" name="">
             <a:extLst xmlns:a="http://schemas.openxmlformats.org/drawingml/2006/main">
               <a:ext uri="{FF2B5EF4-FFF2-40B4-BE49-F238E27FC236}">
-                <a16:creationId xmlns:a16="http://schemas.microsoft.com/office/drawing/2014/main" id="{6A13D807-DB03-4E2F-950A-75C534E935A7}"/>
+                <a16:creationId xmlns:a16="http://schemas.microsoft.com/office/drawing/2014/main" id="{062119A8-B72A-4186-94CD-0A6360C5B1A3}"/>
               </a:ext>
             </a:extLst>
           </p:cNvPr>
@@ -3444,7 +3469,7 @@
           <p:cNvPr id="2" name="">
             <a:extLst xmlns:a="http://schemas.openxmlformats.org/drawingml/2006/main">
               <a:ext uri="{FF2B5EF4-FFF2-40B4-BE49-F238E27FC236}">
-                <a16:creationId xmlns:a16="http://schemas.microsoft.com/office/drawing/2014/main" id="{902882A6-75C7-48FC-B60A-01C24C6603E6}"/>
+                <a16:creationId xmlns:a16="http://schemas.microsoft.com/office/drawing/2014/main" id="{C8840B40-C3FC-4000-AA80-51523A6430FB}"/>
               </a:ext>
             </a:extLst>
           </p:cNvPr>
@@ -3474,7 +3499,7 @@
           <p:cNvPr id="3" name="">
             <a:extLst xmlns:a="http://schemas.openxmlformats.org/drawingml/2006/main">
               <a:ext uri="{FF2B5EF4-FFF2-40B4-BE49-F238E27FC236}">
-                <a16:creationId xmlns:a16="http://schemas.microsoft.com/office/drawing/2014/main" id="{39858E33-E7F2-4CEC-A4B5-C401DFACDFCE}"/>
+                <a16:creationId xmlns:a16="http://schemas.microsoft.com/office/drawing/2014/main" id="{4C0F60B3-6A08-4771-BAB8-A2FBEE8013B7}"/>
               </a:ext>
             </a:extLst>
           </p:cNvPr>
@@ -3531,7 +3556,7 @@
           <p:cNvPr id="4" name="">
             <a:extLst xmlns:a="http://schemas.openxmlformats.org/drawingml/2006/main">
               <a:ext uri="{FF2B5EF4-FFF2-40B4-BE49-F238E27FC236}">
-                <a16:creationId xmlns:a16="http://schemas.microsoft.com/office/drawing/2014/main" id="{59D01074-D4F0-4BCA-833C-F2615019BBB1}"/>
+                <a16:creationId xmlns:a16="http://schemas.microsoft.com/office/drawing/2014/main" id="{CF9DB5DC-9D76-4944-AEC3-355BF0D4B95D}"/>
               </a:ext>
             </a:extLst>
           </p:cNvPr>
@@ -3588,7 +3613,7 @@
           <p:cNvPr id="5" name="">
             <a:extLst xmlns:a="http://schemas.openxmlformats.org/drawingml/2006/main">
               <a:ext uri="{FF2B5EF4-FFF2-40B4-BE49-F238E27FC236}">
-                <a16:creationId xmlns:a16="http://schemas.microsoft.com/office/drawing/2014/main" id="{1DEBE62B-4B21-4C97-B909-032DA005D7E0}"/>
+                <a16:creationId xmlns:a16="http://schemas.microsoft.com/office/drawing/2014/main" id="{953AE7D6-2D0A-4DB0-A0BC-9FE54A8D3811}"/>
               </a:ext>
             </a:extLst>
           </p:cNvPr>
@@ -3645,7 +3670,7 @@
           <p:cNvPr id="6" name="">
             <a:extLst xmlns:a="http://schemas.openxmlformats.org/drawingml/2006/main">
               <a:ext uri="{FF2B5EF4-FFF2-40B4-BE49-F238E27FC236}">
-                <a16:creationId xmlns:a16="http://schemas.microsoft.com/office/drawing/2014/main" id="{26053962-7064-43A8-8FA0-6E86E9911C8B}"/>
+                <a16:creationId xmlns:a16="http://schemas.microsoft.com/office/drawing/2014/main" id="{5504D1E8-8EF7-48B8-B4E9-DAB9D30A7B0D}"/>
               </a:ext>
             </a:extLst>
           </p:cNvPr>
@@ -3702,7 +3727,7 @@
           <p:cNvPr id="7" name="">
             <a:extLst xmlns:a="http://schemas.openxmlformats.org/drawingml/2006/main">
               <a:ext uri="{FF2B5EF4-FFF2-40B4-BE49-F238E27FC236}">
-                <a16:creationId xmlns:a16="http://schemas.microsoft.com/office/drawing/2014/main" id="{0C5D6FBC-4C3F-4CEF-B0D8-E809D58290C3}"/>
+                <a16:creationId xmlns:a16="http://schemas.microsoft.com/office/drawing/2014/main" id="{97A85536-93EB-42A6-BBE0-962F225B05A8}"/>
               </a:ext>
             </a:extLst>
           </p:cNvPr>
@@ -3730,7 +3755,7 @@
           <p:cNvPr id="8" name="">
             <a:extLst xmlns:a="http://schemas.openxmlformats.org/drawingml/2006/main">
               <a:ext uri="{FF2B5EF4-FFF2-40B4-BE49-F238E27FC236}">
-                <a16:creationId xmlns:a16="http://schemas.microsoft.com/office/drawing/2014/main" id="{EF66098B-0C27-44A1-9223-A050BB3293FD}"/>
+                <a16:creationId xmlns:a16="http://schemas.microsoft.com/office/drawing/2014/main" id="{66167B23-644A-4EA1-AD96-AAD10653D5F6}"/>
               </a:ext>
             </a:extLst>
           </p:cNvPr>
@@ -3787,7 +3812,7 @@
           <p:cNvPr id="9" name="">
             <a:extLst xmlns:a="http://schemas.openxmlformats.org/drawingml/2006/main">
               <a:ext uri="{FF2B5EF4-FFF2-40B4-BE49-F238E27FC236}">
-                <a16:creationId xmlns:a16="http://schemas.microsoft.com/office/drawing/2014/main" id="{5F5BE962-939F-4E89-9957-DB3A9DF1321D}"/>
+                <a16:creationId xmlns:a16="http://schemas.microsoft.com/office/drawing/2014/main" id="{05D0EFB7-5B41-4684-A70D-A688E5E7FB41}"/>
               </a:ext>
             </a:extLst>
           </p:cNvPr>
@@ -3817,7 +3842,7 @@
           <p:cNvPr id="10" name="">
             <a:extLst xmlns:a="http://schemas.openxmlformats.org/drawingml/2006/main">
               <a:ext uri="{FF2B5EF4-FFF2-40B4-BE49-F238E27FC236}">
-                <a16:creationId xmlns:a16="http://schemas.microsoft.com/office/drawing/2014/main" id="{AEF88758-8C2C-46FE-B89E-64E99C88E6FE}"/>
+                <a16:creationId xmlns:a16="http://schemas.microsoft.com/office/drawing/2014/main" id="{60D38FE9-432B-4206-A8C6-8421283FEADD}"/>
               </a:ext>
             </a:extLst>
           </p:cNvPr>
@@ -3897,7 +3922,7 @@
           <p:cNvPr id="11" name="">
             <a:extLst xmlns:a="http://schemas.openxmlformats.org/drawingml/2006/main">
               <a:ext uri="{FF2B5EF4-FFF2-40B4-BE49-F238E27FC236}">
-                <a16:creationId xmlns:a16="http://schemas.microsoft.com/office/drawing/2014/main" id="{E811792A-D029-4B54-8682-99634AFB6818}"/>
+                <a16:creationId xmlns:a16="http://schemas.microsoft.com/office/drawing/2014/main" id="{BB14FC85-E45A-4583-A475-4192D185A852}"/>
               </a:ext>
             </a:extLst>
           </p:cNvPr>
@@ -3925,7 +3950,7 @@
           <p:cNvPr id="12" name="">
             <a:extLst xmlns:a="http://schemas.openxmlformats.org/drawingml/2006/main">
               <a:ext uri="{FF2B5EF4-FFF2-40B4-BE49-F238E27FC236}">
-                <a16:creationId xmlns:a16="http://schemas.microsoft.com/office/drawing/2014/main" id="{86E49C38-A939-45F2-9B9D-BAE4B6C788D7}"/>
+                <a16:creationId xmlns:a16="http://schemas.microsoft.com/office/drawing/2014/main" id="{F273D936-356C-4BD1-B61E-22F9B8F93D0E}"/>
               </a:ext>
             </a:extLst>
           </p:cNvPr>
@@ -3982,7 +4007,7 @@
           <p:cNvPr id="13" name="">
             <a:extLst xmlns:a="http://schemas.openxmlformats.org/drawingml/2006/main">
               <a:ext uri="{FF2B5EF4-FFF2-40B4-BE49-F238E27FC236}">
-                <a16:creationId xmlns:a16="http://schemas.microsoft.com/office/drawing/2014/main" id="{44FB94AD-D2BE-4476-B621-7AE91F1ADE60}"/>
+                <a16:creationId xmlns:a16="http://schemas.microsoft.com/office/drawing/2014/main" id="{0647CEC8-A9C6-4FC3-9941-A51A40374187}"/>
               </a:ext>
             </a:extLst>
           </p:cNvPr>
@@ -4012,7 +4037,7 @@
           <p:cNvPr id="14" name="">
             <a:extLst xmlns:a="http://schemas.openxmlformats.org/drawingml/2006/main">
               <a:ext uri="{FF2B5EF4-FFF2-40B4-BE49-F238E27FC236}">
-                <a16:creationId xmlns:a16="http://schemas.microsoft.com/office/drawing/2014/main" id="{1F7D9962-BB6E-41FF-8A52-DF90DDBCB830}"/>
+                <a16:creationId xmlns:a16="http://schemas.microsoft.com/office/drawing/2014/main" id="{3D5D5B4B-87A6-4F0B-B61B-B0221AF23312}"/>
               </a:ext>
             </a:extLst>
           </p:cNvPr>
@@ -4092,7 +4117,7 @@
           <p:cNvPr id="15" name="">
             <a:extLst xmlns:a="http://schemas.openxmlformats.org/drawingml/2006/main">
               <a:ext uri="{FF2B5EF4-FFF2-40B4-BE49-F238E27FC236}">
-                <a16:creationId xmlns:a16="http://schemas.microsoft.com/office/drawing/2014/main" id="{72EC4228-3D33-4B80-AA8B-E8696AED233A}"/>
+                <a16:creationId xmlns:a16="http://schemas.microsoft.com/office/drawing/2014/main" id="{C352B214-B302-49BA-ADBC-6A18114B413D}"/>
               </a:ext>
             </a:extLst>
           </p:cNvPr>
@@ -4120,7 +4145,7 @@
           <p:cNvPr id="16" name="">
             <a:extLst xmlns:a="http://schemas.openxmlformats.org/drawingml/2006/main">
               <a:ext uri="{FF2B5EF4-FFF2-40B4-BE49-F238E27FC236}">
-                <a16:creationId xmlns:a16="http://schemas.microsoft.com/office/drawing/2014/main" id="{7E79C377-13B4-43D4-95D3-FFBF2D68403C}"/>
+                <a16:creationId xmlns:a16="http://schemas.microsoft.com/office/drawing/2014/main" id="{05633805-53FC-4315-B47D-C2AD0539E1D0}"/>
               </a:ext>
             </a:extLst>
           </p:cNvPr>
@@ -4177,7 +4202,7 @@
           <p:cNvPr id="17" name="">
             <a:extLst xmlns:a="http://schemas.openxmlformats.org/drawingml/2006/main">
               <a:ext uri="{FF2B5EF4-FFF2-40B4-BE49-F238E27FC236}">
-                <a16:creationId xmlns:a16="http://schemas.microsoft.com/office/drawing/2014/main" id="{71D03059-0BEC-4852-9633-04D590CEA5C5}"/>
+                <a16:creationId xmlns:a16="http://schemas.microsoft.com/office/drawing/2014/main" id="{E7DBDD7B-AB99-4D45-98E3-E36F11321A75}"/>
               </a:ext>
             </a:extLst>
           </p:cNvPr>
@@ -4207,7 +4232,7 @@
           <p:cNvPr id="18" name="">
             <a:extLst xmlns:a="http://schemas.openxmlformats.org/drawingml/2006/main">
               <a:ext uri="{FF2B5EF4-FFF2-40B4-BE49-F238E27FC236}">
-                <a16:creationId xmlns:a16="http://schemas.microsoft.com/office/drawing/2014/main" id="{CBFF2838-59FC-45E0-A922-16CF1BB3035C}"/>
+                <a16:creationId xmlns:a16="http://schemas.microsoft.com/office/drawing/2014/main" id="{07282E7F-B4C8-43DA-B757-52C74FAEB304}"/>
               </a:ext>
             </a:extLst>
           </p:cNvPr>
@@ -4287,7 +4312,7 @@
           <p:cNvPr id="19" name="">
             <a:extLst xmlns:a="http://schemas.openxmlformats.org/drawingml/2006/main">
               <a:ext uri="{FF2B5EF4-FFF2-40B4-BE49-F238E27FC236}">
-                <a16:creationId xmlns:a16="http://schemas.microsoft.com/office/drawing/2014/main" id="{538141E5-F1E5-4C73-A002-03869B8080D9}"/>
+                <a16:creationId xmlns:a16="http://schemas.microsoft.com/office/drawing/2014/main" id="{DCA7D4D8-D2D0-401F-B355-69C6D0A9C95E}"/>
               </a:ext>
             </a:extLst>
           </p:cNvPr>
@@ -4315,7 +4340,7 @@
           <p:cNvPr id="20" name="">
             <a:extLst xmlns:a="http://schemas.openxmlformats.org/drawingml/2006/main">
               <a:ext uri="{FF2B5EF4-FFF2-40B4-BE49-F238E27FC236}">
-                <a16:creationId xmlns:a16="http://schemas.microsoft.com/office/drawing/2014/main" id="{9C6DF48A-017D-4E51-940F-A0EF796A648C}"/>
+                <a16:creationId xmlns:a16="http://schemas.microsoft.com/office/drawing/2014/main" id="{BE1960FF-1ACD-48DA-8DC6-FC3991B3F23F}"/>
               </a:ext>
             </a:extLst>
           </p:cNvPr>
@@ -4372,7 +4397,7 @@
           <p:cNvPr id="21" name="">
             <a:extLst xmlns:a="http://schemas.openxmlformats.org/drawingml/2006/main">
               <a:ext uri="{FF2B5EF4-FFF2-40B4-BE49-F238E27FC236}">
-                <a16:creationId xmlns:a16="http://schemas.microsoft.com/office/drawing/2014/main" id="{01F863E2-CF13-47D5-B8FB-7E2040D6BF52}"/>
+                <a16:creationId xmlns:a16="http://schemas.microsoft.com/office/drawing/2014/main" id="{5D51C37A-996D-4A33-8E38-E6764120AFB9}"/>
               </a:ext>
             </a:extLst>
           </p:cNvPr>
@@ -4402,7 +4427,7 @@
           <p:cNvPr id="22" name="">
             <a:extLst xmlns:a="http://schemas.openxmlformats.org/drawingml/2006/main">
               <a:ext uri="{FF2B5EF4-FFF2-40B4-BE49-F238E27FC236}">
-                <a16:creationId xmlns:a16="http://schemas.microsoft.com/office/drawing/2014/main" id="{F48106F8-DBA1-422D-8A73-1FD91FD996E0}"/>
+                <a16:creationId xmlns:a16="http://schemas.microsoft.com/office/drawing/2014/main" id="{7ADCB0F9-67F5-4380-ADAD-EDCAE878DBF5}"/>
               </a:ext>
             </a:extLst>
           </p:cNvPr>
@@ -4482,7 +4507,7 @@
           <p:cNvPr id="23" name="">
             <a:extLst xmlns:a="http://schemas.openxmlformats.org/drawingml/2006/main">
               <a:ext uri="{FF2B5EF4-FFF2-40B4-BE49-F238E27FC236}">
-                <a16:creationId xmlns:a16="http://schemas.microsoft.com/office/drawing/2014/main" id="{9B576209-E315-46E5-BEF2-5C3437D97108}"/>
+                <a16:creationId xmlns:a16="http://schemas.microsoft.com/office/drawing/2014/main" id="{D1961F66-54F5-4836-8962-4D0B83C68618}"/>
               </a:ext>
             </a:extLst>
           </p:cNvPr>
@@ -4510,7 +4535,7 @@
           <p:cNvPr id="24" name="">
             <a:extLst xmlns:a="http://schemas.openxmlformats.org/drawingml/2006/main">
               <a:ext uri="{FF2B5EF4-FFF2-40B4-BE49-F238E27FC236}">
-                <a16:creationId xmlns:a16="http://schemas.microsoft.com/office/drawing/2014/main" id="{BE212C12-E28F-4DEE-83F0-D09DC0994DC8}"/>
+                <a16:creationId xmlns:a16="http://schemas.microsoft.com/office/drawing/2014/main" id="{51BD8417-4C2E-4308-BE38-FAE6898C9C50}"/>
               </a:ext>
             </a:extLst>
           </p:cNvPr>
@@ -4567,7 +4592,7 @@
           <p:cNvPr id="25" name="">
             <a:extLst xmlns:a="http://schemas.openxmlformats.org/drawingml/2006/main">
               <a:ext uri="{FF2B5EF4-FFF2-40B4-BE49-F238E27FC236}">
-                <a16:creationId xmlns:a16="http://schemas.microsoft.com/office/drawing/2014/main" id="{B9284083-0116-48C9-A4C3-F07F307C2ED7}"/>
+                <a16:creationId xmlns:a16="http://schemas.microsoft.com/office/drawing/2014/main" id="{305E8ADE-314F-41C5-8035-CA0E9221CD8B}"/>
               </a:ext>
             </a:extLst>
           </p:cNvPr>
@@ -4597,7 +4622,7 @@
           <p:cNvPr id="26" name="">
             <a:extLst xmlns:a="http://schemas.openxmlformats.org/drawingml/2006/main">
               <a:ext uri="{FF2B5EF4-FFF2-40B4-BE49-F238E27FC236}">
-                <a16:creationId xmlns:a16="http://schemas.microsoft.com/office/drawing/2014/main" id="{A01D2851-C340-418A-8552-1403B5311470}"/>
+                <a16:creationId xmlns:a16="http://schemas.microsoft.com/office/drawing/2014/main" id="{2092F0BD-37B1-4AF7-99D4-917E46BE6887}"/>
               </a:ext>
             </a:extLst>
           </p:cNvPr>
@@ -4677,7 +4702,7 @@
           <p:cNvPr id="27" name="">
             <a:extLst xmlns:a="http://schemas.openxmlformats.org/drawingml/2006/main">
               <a:ext uri="{FF2B5EF4-FFF2-40B4-BE49-F238E27FC236}">
-                <a16:creationId xmlns:a16="http://schemas.microsoft.com/office/drawing/2014/main" id="{02296C83-0445-47C0-AA6D-9A8718BD364B}"/>
+                <a16:creationId xmlns:a16="http://schemas.microsoft.com/office/drawing/2014/main" id="{2C9C82E1-F8EB-430C-A331-AAA5088F830F}"/>
               </a:ext>
             </a:extLst>
           </p:cNvPr>
@@ -4705,7 +4730,7 @@
           <p:cNvPr id="28" name="">
             <a:extLst xmlns:a="http://schemas.openxmlformats.org/drawingml/2006/main">
               <a:ext uri="{FF2B5EF4-FFF2-40B4-BE49-F238E27FC236}">
-                <a16:creationId xmlns:a16="http://schemas.microsoft.com/office/drawing/2014/main" id="{E8A75EDC-6DDD-4250-A1DB-BDB9D933CA77}"/>
+                <a16:creationId xmlns:a16="http://schemas.microsoft.com/office/drawing/2014/main" id="{31A66588-B9DF-4AAE-A4E2-53D2127A4874}"/>
               </a:ext>
             </a:extLst>
           </p:cNvPr>
@@ -4762,7 +4787,7 @@
           <p:cNvPr id="29" name="">
             <a:extLst xmlns:a="http://schemas.openxmlformats.org/drawingml/2006/main">
               <a:ext uri="{FF2B5EF4-FFF2-40B4-BE49-F238E27FC236}">
-                <a16:creationId xmlns:a16="http://schemas.microsoft.com/office/drawing/2014/main" id="{4C0DE860-17E2-480D-9A8B-BA9C8C2B19F4}"/>
+                <a16:creationId xmlns:a16="http://schemas.microsoft.com/office/drawing/2014/main" id="{60CBE930-8318-4F75-8A37-11F845DBDDEA}"/>
               </a:ext>
             </a:extLst>
           </p:cNvPr>
@@ -4792,7 +4817,7 @@
           <p:cNvPr id="30" name="">
             <a:extLst xmlns:a="http://schemas.openxmlformats.org/drawingml/2006/main">
               <a:ext uri="{FF2B5EF4-FFF2-40B4-BE49-F238E27FC236}">
-                <a16:creationId xmlns:a16="http://schemas.microsoft.com/office/drawing/2014/main" id="{C73C92FB-72C5-4A03-A42A-B6CF37CAA7B3}"/>
+                <a16:creationId xmlns:a16="http://schemas.microsoft.com/office/drawing/2014/main" id="{2EEB660F-8567-4523-B63F-7A41E0EC9C52}"/>
               </a:ext>
             </a:extLst>
           </p:cNvPr>
@@ -4872,7 +4897,7 @@
           <p:cNvPr id="31" name="">
             <a:extLst xmlns:a="http://schemas.openxmlformats.org/drawingml/2006/main">
               <a:ext uri="{FF2B5EF4-FFF2-40B4-BE49-F238E27FC236}">
-                <a16:creationId xmlns:a16="http://schemas.microsoft.com/office/drawing/2014/main" id="{0C9EAF6C-2459-463B-A857-8D84B5187604}"/>
+                <a16:creationId xmlns:a16="http://schemas.microsoft.com/office/drawing/2014/main" id="{BD2C9165-871B-454B-B4CD-05C9E9C0B901}"/>
               </a:ext>
             </a:extLst>
           </p:cNvPr>
@@ -4900,7 +4925,7 @@
           <p:cNvPr id="32" name="">
             <a:extLst xmlns:a="http://schemas.openxmlformats.org/drawingml/2006/main">
               <a:ext uri="{FF2B5EF4-FFF2-40B4-BE49-F238E27FC236}">
-                <a16:creationId xmlns:a16="http://schemas.microsoft.com/office/drawing/2014/main" id="{E32CF797-C025-4CE4-BC07-B4C31855A301}"/>
+                <a16:creationId xmlns:a16="http://schemas.microsoft.com/office/drawing/2014/main" id="{69FDE02B-3E94-4372-B966-6B87394A8A55}"/>
               </a:ext>
             </a:extLst>
           </p:cNvPr>
@@ -4957,7 +4982,7 @@
           <p:cNvPr id="33" name="">
             <a:extLst xmlns:a="http://schemas.openxmlformats.org/drawingml/2006/main">
               <a:ext uri="{FF2B5EF4-FFF2-40B4-BE49-F238E27FC236}">
-                <a16:creationId xmlns:a16="http://schemas.microsoft.com/office/drawing/2014/main" id="{209972D8-FF00-483B-8543-E0BB80F7C5C4}"/>
+                <a16:creationId xmlns:a16="http://schemas.microsoft.com/office/drawing/2014/main" id="{7B163A8E-E904-4A3F-9A22-6E0292CAC722}"/>
               </a:ext>
             </a:extLst>
           </p:cNvPr>
@@ -4987,7 +5012,7 @@
           <p:cNvPr id="34" name="">
             <a:extLst xmlns:a="http://schemas.openxmlformats.org/drawingml/2006/main">
               <a:ext uri="{FF2B5EF4-FFF2-40B4-BE49-F238E27FC236}">
-                <a16:creationId xmlns:a16="http://schemas.microsoft.com/office/drawing/2014/main" id="{AA6649F8-DBD8-4183-AA70-DB3D8B67E653}"/>
+                <a16:creationId xmlns:a16="http://schemas.microsoft.com/office/drawing/2014/main" id="{8D7780C1-B646-442D-A5CD-36153A634580}"/>
               </a:ext>
             </a:extLst>
           </p:cNvPr>
@@ -5067,7 +5092,7 @@
           <p:cNvPr id="35" name="">
             <a:extLst xmlns:a="http://schemas.openxmlformats.org/drawingml/2006/main">
               <a:ext uri="{FF2B5EF4-FFF2-40B4-BE49-F238E27FC236}">
-                <a16:creationId xmlns:a16="http://schemas.microsoft.com/office/drawing/2014/main" id="{798C0332-17C5-4DF7-BAA2-7BFA7143E1EE}"/>
+                <a16:creationId xmlns:a16="http://schemas.microsoft.com/office/drawing/2014/main" id="{D7F5E057-5CEF-4427-8365-D1E01BE1A482}"/>
               </a:ext>
             </a:extLst>
           </p:cNvPr>
@@ -5095,7 +5120,7 @@
           <p:cNvPr id="36" name="">
             <a:extLst xmlns:a="http://schemas.openxmlformats.org/drawingml/2006/main">
               <a:ext uri="{FF2B5EF4-FFF2-40B4-BE49-F238E27FC236}">
-                <a16:creationId xmlns:a16="http://schemas.microsoft.com/office/drawing/2014/main" id="{044C2F16-F337-4BBE-AC1C-7A0239BCBD9C}"/>
+                <a16:creationId xmlns:a16="http://schemas.microsoft.com/office/drawing/2014/main" id="{9AD858C2-0FC7-4415-888D-753A1051DDE4}"/>
               </a:ext>
             </a:extLst>
           </p:cNvPr>
@@ -5152,7 +5177,7 @@
           <p:cNvPr id="37" name="">
             <a:extLst xmlns:a="http://schemas.openxmlformats.org/drawingml/2006/main">
               <a:ext uri="{FF2B5EF4-FFF2-40B4-BE49-F238E27FC236}">
-                <a16:creationId xmlns:a16="http://schemas.microsoft.com/office/drawing/2014/main" id="{0C64D53B-B445-4351-AB90-1052A0687FE7}"/>
+                <a16:creationId xmlns:a16="http://schemas.microsoft.com/office/drawing/2014/main" id="{DD0F5CED-0497-4450-8C1B-BA77A9350939}"/>
               </a:ext>
             </a:extLst>
           </p:cNvPr>
@@ -5182,7 +5207,7 @@
           <p:cNvPr id="38" name="">
             <a:extLst xmlns:a="http://schemas.openxmlformats.org/drawingml/2006/main">
               <a:ext uri="{FF2B5EF4-FFF2-40B4-BE49-F238E27FC236}">
-                <a16:creationId xmlns:a16="http://schemas.microsoft.com/office/drawing/2014/main" id="{C804A706-6F52-4CDB-A086-07873FDFCC1B}"/>
+                <a16:creationId xmlns:a16="http://schemas.microsoft.com/office/drawing/2014/main" id="{336D1030-010D-48CD-B37A-FA4719AD0D74}"/>
               </a:ext>
             </a:extLst>
           </p:cNvPr>
@@ -5262,7 +5287,7 @@
           <p:cNvPr id="39" name="">
             <a:extLst xmlns:a="http://schemas.openxmlformats.org/drawingml/2006/main">
               <a:ext uri="{FF2B5EF4-FFF2-40B4-BE49-F238E27FC236}">
-                <a16:creationId xmlns:a16="http://schemas.microsoft.com/office/drawing/2014/main" id="{A05CBF11-6E4E-49EA-8C9E-C85BA13A5D3E}"/>
+                <a16:creationId xmlns:a16="http://schemas.microsoft.com/office/drawing/2014/main" id="{85C15D18-081E-46D4-907D-4C2D0C3ED4D7}"/>
               </a:ext>
             </a:extLst>
           </p:cNvPr>
@@ -5290,7 +5315,7 @@
           <p:cNvPr id="40" name="">
             <a:extLst xmlns:a="http://schemas.openxmlformats.org/drawingml/2006/main">
               <a:ext uri="{FF2B5EF4-FFF2-40B4-BE49-F238E27FC236}">
-                <a16:creationId xmlns:a16="http://schemas.microsoft.com/office/drawing/2014/main" id="{E440A5E6-D955-49F7-8F26-12640304BC1F}"/>
+                <a16:creationId xmlns:a16="http://schemas.microsoft.com/office/drawing/2014/main" id="{F0915395-13FA-40B3-85D8-5052EBE384A1}"/>
               </a:ext>
             </a:extLst>
           </p:cNvPr>
@@ -5347,7 +5372,7 @@
           <p:cNvPr id="41" name="">
             <a:extLst xmlns:a="http://schemas.openxmlformats.org/drawingml/2006/main">
               <a:ext uri="{FF2B5EF4-FFF2-40B4-BE49-F238E27FC236}">
-                <a16:creationId xmlns:a16="http://schemas.microsoft.com/office/drawing/2014/main" id="{2C32FCC6-219D-4D1E-A388-9A8E90B96398}"/>
+                <a16:creationId xmlns:a16="http://schemas.microsoft.com/office/drawing/2014/main" id="{E7BA170E-A62A-4432-A3E1-CB94DF9A64ED}"/>
               </a:ext>
             </a:extLst>
           </p:cNvPr>
@@ -5377,7 +5402,7 @@
           <p:cNvPr id="42" name="">
             <a:extLst xmlns:a="http://schemas.openxmlformats.org/drawingml/2006/main">
               <a:ext uri="{FF2B5EF4-FFF2-40B4-BE49-F238E27FC236}">
-                <a16:creationId xmlns:a16="http://schemas.microsoft.com/office/drawing/2014/main" id="{B48F5BDC-B87E-4D5A-AE75-AD3171C6E4A4}"/>
+                <a16:creationId xmlns:a16="http://schemas.microsoft.com/office/drawing/2014/main" id="{B2098A97-241F-4EAD-B652-AD0128D89413}"/>
               </a:ext>
             </a:extLst>
           </p:cNvPr>
@@ -5457,7 +5482,7 @@
           <p:cNvPr id="43" name="">
             <a:extLst xmlns:a="http://schemas.openxmlformats.org/drawingml/2006/main">
               <a:ext uri="{FF2B5EF4-FFF2-40B4-BE49-F238E27FC236}">
-                <a16:creationId xmlns:a16="http://schemas.microsoft.com/office/drawing/2014/main" id="{AA4BCAF6-C137-4B85-ABFE-6B09F228FEA8}"/>
+                <a16:creationId xmlns:a16="http://schemas.microsoft.com/office/drawing/2014/main" id="{3C4C230E-1D61-41E4-B8C4-4136C7B11C0F}"/>
               </a:ext>
             </a:extLst>
           </p:cNvPr>
@@ -5485,7 +5510,7 @@
           <p:cNvPr id="44" name="">
             <a:extLst xmlns:a="http://schemas.openxmlformats.org/drawingml/2006/main">
               <a:ext uri="{FF2B5EF4-FFF2-40B4-BE49-F238E27FC236}">
-                <a16:creationId xmlns:a16="http://schemas.microsoft.com/office/drawing/2014/main" id="{432640C9-0B8D-48C1-9261-4EA177775C2B}"/>
+                <a16:creationId xmlns:a16="http://schemas.microsoft.com/office/drawing/2014/main" id="{590D64BE-5627-4576-AE74-71E14231CA75}"/>
               </a:ext>
             </a:extLst>
           </p:cNvPr>
@@ -5542,7 +5567,7 @@
           <p:cNvPr id="45" name="">
             <a:extLst xmlns:a="http://schemas.openxmlformats.org/drawingml/2006/main">
               <a:ext uri="{FF2B5EF4-FFF2-40B4-BE49-F238E27FC236}">
-                <a16:creationId xmlns:a16="http://schemas.microsoft.com/office/drawing/2014/main" id="{86FBC0A7-227E-4566-9297-A0166030FDC3}"/>
+                <a16:creationId xmlns:a16="http://schemas.microsoft.com/office/drawing/2014/main" id="{6DEB19DB-F92E-45EA-9C56-776B40D6B489}"/>
               </a:ext>
             </a:extLst>
           </p:cNvPr>
@@ -5572,7 +5597,7 @@
           <p:cNvPr id="46" name="">
             <a:extLst xmlns:a="http://schemas.openxmlformats.org/drawingml/2006/main">
               <a:ext uri="{FF2B5EF4-FFF2-40B4-BE49-F238E27FC236}">
-                <a16:creationId xmlns:a16="http://schemas.microsoft.com/office/drawing/2014/main" id="{E19D5482-97DB-43F7-84FC-9283D92C860C}"/>
+                <a16:creationId xmlns:a16="http://schemas.microsoft.com/office/drawing/2014/main" id="{FE3EE52F-030B-42E3-9A71-01CFB781440E}"/>
               </a:ext>
             </a:extLst>
           </p:cNvPr>
@@ -5877,7 +5902,7 @@
           <p:cNvPr id="56" name="">
             <a:extLst xmlns:a="http://schemas.openxmlformats.org/drawingml/2006/main">
               <a:ext uri="{FF2B5EF4-FFF2-40B4-BE49-F238E27FC236}">
-                <a16:creationId xmlns:a16="http://schemas.microsoft.com/office/drawing/2014/main" id="{22C58892-6FFF-441D-A91E-BA6038F16747}"/>
+                <a16:creationId xmlns:a16="http://schemas.microsoft.com/office/drawing/2014/main" id="{ED40F6D8-E96A-44A5-91AD-7FAE131DE458}"/>
               </a:ext>
             </a:extLst>
           </p:cNvPr>
@@ -5934,7 +5959,7 @@
           <p:cNvPr id="57" name="">
             <a:extLst xmlns:a="http://schemas.openxmlformats.org/drawingml/2006/main">
               <a:ext uri="{FF2B5EF4-FFF2-40B4-BE49-F238E27FC236}">
-                <a16:creationId xmlns:a16="http://schemas.microsoft.com/office/drawing/2014/main" id="{EF09786F-386B-49C6-ACDB-BE637F189C1E}"/>
+                <a16:creationId xmlns:a16="http://schemas.microsoft.com/office/drawing/2014/main" id="{13D3F89C-63C9-410D-ACA3-82A1661E4218}"/>
               </a:ext>
             </a:extLst>
           </p:cNvPr>
@@ -5989,7 +6014,7 @@
     </p:spTree>
     <p:extLst>
       <p:ext uri="{BB962C8B-B14F-4D97-AF65-F5344CB8AC3E}">
-        <p14:creationId xmlns:p14="http://schemas.microsoft.com/office/powerpoint/2010/main" val="758712969"/>
+        <p14:creationId xmlns:p14="http://schemas.microsoft.com/office/powerpoint/2010/main" val="211860750"/>
       </p:ext>
     </p:extLst>
   </p:cSld>
@@ -6020,7 +6045,7 @@
           <p:cNvPr id="12" name="">
             <a:extLst xmlns:a="http://schemas.openxmlformats.org/drawingml/2006/main">
               <a:ext uri="{FF2B5EF4-FFF2-40B4-BE49-F238E27FC236}">
-                <a16:creationId xmlns:a16="http://schemas.microsoft.com/office/drawing/2014/main" id="{F6DD2A06-CEF1-4BCD-81EB-73FDDE051E74}"/>
+                <a16:creationId xmlns:a16="http://schemas.microsoft.com/office/drawing/2014/main" id="{4F214116-CAD7-4531-AC7F-C0D4B8B1133C}"/>
               </a:ext>
             </a:extLst>
           </p:cNvPr>
@@ -6077,7 +6102,7 @@
           <p:cNvPr id="2" name="">
             <a:extLst xmlns:a="http://schemas.openxmlformats.org/drawingml/2006/main">
               <a:ext uri="{FF2B5EF4-FFF2-40B4-BE49-F238E27FC236}">
-                <a16:creationId xmlns:a16="http://schemas.microsoft.com/office/drawing/2014/main" id="{51A5947F-6A76-42C6-84E5-5690BCE60DE7}"/>
+                <a16:creationId xmlns:a16="http://schemas.microsoft.com/office/drawing/2014/main" id="{565DD42C-0D49-4570-BC64-1FA96F23A9DD}"/>
               </a:ext>
             </a:extLst>
           </p:cNvPr>
@@ -6107,7 +6132,7 @@
           <p:cNvPr id="3" name="">
             <a:extLst xmlns:a="http://schemas.openxmlformats.org/drawingml/2006/main">
               <a:ext uri="{FF2B5EF4-FFF2-40B4-BE49-F238E27FC236}">
-                <a16:creationId xmlns:a16="http://schemas.microsoft.com/office/drawing/2014/main" id="{F0DD799D-E729-4A65-8CE9-6C497618A09E}"/>
+                <a16:creationId xmlns:a16="http://schemas.microsoft.com/office/drawing/2014/main" id="{7F95C882-D52A-4374-92D5-0A87C6B1BBEB}"/>
               </a:ext>
             </a:extLst>
           </p:cNvPr>
@@ -6164,7 +6189,7 @@
           <p:cNvPr id="4" name="">
             <a:extLst xmlns:a="http://schemas.openxmlformats.org/drawingml/2006/main">
               <a:ext uri="{FF2B5EF4-FFF2-40B4-BE49-F238E27FC236}">
-                <a16:creationId xmlns:a16="http://schemas.microsoft.com/office/drawing/2014/main" id="{92784A86-1C14-4209-B4D4-49C08FE1C8BC}"/>
+                <a16:creationId xmlns:a16="http://schemas.microsoft.com/office/drawing/2014/main" id="{15A5CEDD-D5B7-4B24-A86B-96A75E25606B}"/>
               </a:ext>
             </a:extLst>
           </p:cNvPr>
@@ -6221,7 +6246,7 @@
           <p:cNvPr id="5" name="">
             <a:extLst xmlns:a="http://schemas.openxmlformats.org/drawingml/2006/main">
               <a:ext uri="{FF2B5EF4-FFF2-40B4-BE49-F238E27FC236}">
-                <a16:creationId xmlns:a16="http://schemas.microsoft.com/office/drawing/2014/main" id="{77C9031E-21E5-43E7-932E-0097742ECC20}"/>
+                <a16:creationId xmlns:a16="http://schemas.microsoft.com/office/drawing/2014/main" id="{CF665E81-C7BE-4ADB-89E5-59F0F5087E37}"/>
               </a:ext>
             </a:extLst>
           </p:cNvPr>
@@ -6285,7 +6310,7 @@
         </p:xfrm>
         <a:graphic xmlns:a="http://schemas.openxmlformats.org/drawingml/2006/main">
           <a:graphicData uri="http://schemas.openxmlformats.org/drawingml/2006/chart">
-            <c:chart xmlns:r="http://schemas.openxmlformats.org/officeDocument/2006/relationships" xmlns:c="http://schemas.openxmlformats.org/drawingml/2006/chart" r:id="R3745892191e44047"/>
+            <c:chart xmlns:r="http://schemas.openxmlformats.org/officeDocument/2006/relationships" xmlns:c="http://schemas.openxmlformats.org/drawingml/2006/chart" r:id="R4d59c7667ec2488b"/>
           </a:graphicData>
         </a:graphic>
       </p:graphicFrame>
@@ -6294,7 +6319,7 @@
           <p:cNvPr id="7" name="">
             <a:extLst xmlns:a="http://schemas.openxmlformats.org/drawingml/2006/main">
               <a:ext uri="{FF2B5EF4-FFF2-40B4-BE49-F238E27FC236}">
-                <a16:creationId xmlns:a16="http://schemas.microsoft.com/office/drawing/2014/main" id="{E68F5AED-8F1B-4E3C-AB64-712D448188B2}"/>
+                <a16:creationId xmlns:a16="http://schemas.microsoft.com/office/drawing/2014/main" id="{614CC316-A3FF-46A7-AB50-26C299603F21}"/>
               </a:ext>
             </a:extLst>
           </p:cNvPr>
@@ -6351,7 +6376,7 @@
           <p:cNvPr id="8" name="">
             <a:extLst xmlns:a="http://schemas.openxmlformats.org/drawingml/2006/main">
               <a:ext uri="{FF2B5EF4-FFF2-40B4-BE49-F238E27FC236}">
-                <a16:creationId xmlns:a16="http://schemas.microsoft.com/office/drawing/2014/main" id="{F9845862-E5F7-404F-8271-1F833E2A5C65}"/>
+                <a16:creationId xmlns:a16="http://schemas.microsoft.com/office/drawing/2014/main" id="{86693ADE-6017-45B6-8DD1-AC13231D6F00}"/>
               </a:ext>
             </a:extLst>
           </p:cNvPr>
@@ -6381,7 +6406,7 @@
           <p:cNvPr id="9" name="">
             <a:extLst xmlns:a="http://schemas.openxmlformats.org/drawingml/2006/main">
               <a:ext uri="{FF2B5EF4-FFF2-40B4-BE49-F238E27FC236}">
-                <a16:creationId xmlns:a16="http://schemas.microsoft.com/office/drawing/2014/main" id="{A7160B25-AB40-4CA2-820B-CA7000D585C8}"/>
+                <a16:creationId xmlns:a16="http://schemas.microsoft.com/office/drawing/2014/main" id="{8807E750-3CB6-452A-B354-E27B7BF5583C}"/>
               </a:ext>
             </a:extLst>
           </p:cNvPr>
@@ -6484,7 +6509,7 @@
           <p:cNvPr id="10" name="">
             <a:extLst xmlns:a="http://schemas.openxmlformats.org/drawingml/2006/main">
               <a:ext uri="{FF2B5EF4-FFF2-40B4-BE49-F238E27FC236}">
-                <a16:creationId xmlns:a16="http://schemas.microsoft.com/office/drawing/2014/main" id="{00EBBC9B-58C3-4A14-A0C9-43EC89EE6648}"/>
+                <a16:creationId xmlns:a16="http://schemas.microsoft.com/office/drawing/2014/main" id="{90D9187B-9131-4346-84AD-E7DC14A971ED}"/>
               </a:ext>
             </a:extLst>
           </p:cNvPr>
@@ -6531,7 +6556,7 @@
                 <a:ea typeface="Arial"/>
                 <a:cs typeface="Arial"/>
               </a:rPr>
-              <a:t>Next: real water use</a:t>
+              <a:t>Next: train and test</a:t>
             </a:r>
           </a:p>
           <a:p xmlns:a="http://schemas.openxmlformats.org/drawingml/2006/main">
@@ -6554,7 +6579,7 @@
                 <a:ea typeface="Arial"/>
                 <a:cs typeface="Arial"/>
               </a:rPr>
-              <a:t>and area measurements.</a:t>
+              <a:t>on real measurements.</a:t>
             </a:r>
           </a:p>
         </p:txBody>
@@ -6564,7 +6589,7 @@
           <p:cNvPr id="11" name="">
             <a:extLst xmlns:a="http://schemas.openxmlformats.org/drawingml/2006/main">
               <a:ext uri="{FF2B5EF4-FFF2-40B4-BE49-F238E27FC236}">
-                <a16:creationId xmlns:a16="http://schemas.microsoft.com/office/drawing/2014/main" id="{F3B0D266-41D3-4A9D-8AFA-861411695280}"/>
+                <a16:creationId xmlns:a16="http://schemas.microsoft.com/office/drawing/2014/main" id="{C1DC3C26-DF6C-44A9-9752-903C15D8B461}"/>
               </a:ext>
             </a:extLst>
           </p:cNvPr>
@@ -6642,7 +6667,7 @@
     </p:spTree>
     <p:extLst>
       <p:ext uri="{BB962C8B-B14F-4D97-AF65-F5344CB8AC3E}">
-        <p14:creationId xmlns:p14="http://schemas.microsoft.com/office/powerpoint/2010/main" val="1010966740"/>
+        <p14:creationId xmlns:p14="http://schemas.microsoft.com/office/powerpoint/2010/main" val="803390419"/>
       </p:ext>
     </p:extLst>
   </p:cSld>
@@ -6673,7 +6698,7 @@
           <p:cNvPr id="14" name="">
             <a:extLst xmlns:a="http://schemas.openxmlformats.org/drawingml/2006/main">
               <a:ext uri="{FF2B5EF4-FFF2-40B4-BE49-F238E27FC236}">
-                <a16:creationId xmlns:a16="http://schemas.microsoft.com/office/drawing/2014/main" id="{637CFA71-841A-4CD0-971D-01846F3A06BF}"/>
+                <a16:creationId xmlns:a16="http://schemas.microsoft.com/office/drawing/2014/main" id="{E9F5AE39-60C5-474B-B2C5-09BCF9C8D90E}"/>
               </a:ext>
             </a:extLst>
           </p:cNvPr>
@@ -6730,7 +6755,7 @@
           <p:cNvPr id="2" name="">
             <a:extLst xmlns:a="http://schemas.openxmlformats.org/drawingml/2006/main">
               <a:ext uri="{FF2B5EF4-FFF2-40B4-BE49-F238E27FC236}">
-                <a16:creationId xmlns:a16="http://schemas.microsoft.com/office/drawing/2014/main" id="{FD614480-E71F-44A5-B52D-76C557F1F36B}"/>
+                <a16:creationId xmlns:a16="http://schemas.microsoft.com/office/drawing/2014/main" id="{1A87CE41-8959-4A25-A264-A5A272A06CF2}"/>
               </a:ext>
             </a:extLst>
           </p:cNvPr>
@@ -6760,7 +6785,7 @@
           <p:cNvPr id="3" name="">
             <a:extLst xmlns:a="http://schemas.openxmlformats.org/drawingml/2006/main">
               <a:ext uri="{FF2B5EF4-FFF2-40B4-BE49-F238E27FC236}">
-                <a16:creationId xmlns:a16="http://schemas.microsoft.com/office/drawing/2014/main" id="{538E8079-9AB5-4A08-AE24-5004B0A804AE}"/>
+                <a16:creationId xmlns:a16="http://schemas.microsoft.com/office/drawing/2014/main" id="{41093080-5E95-418F-B5A2-6F2E464F2FEC}"/>
               </a:ext>
             </a:extLst>
           </p:cNvPr>
@@ -6817,7 +6842,7 @@
           <p:cNvPr id="4" name="">
             <a:extLst xmlns:a="http://schemas.openxmlformats.org/drawingml/2006/main">
               <a:ext uri="{FF2B5EF4-FFF2-40B4-BE49-F238E27FC236}">
-                <a16:creationId xmlns:a16="http://schemas.microsoft.com/office/drawing/2014/main" id="{7B49761C-95D0-4EC5-BA73-D5C60C1E2858}"/>
+                <a16:creationId xmlns:a16="http://schemas.microsoft.com/office/drawing/2014/main" id="{119B99B1-B338-434A-AE7E-DF6D5EFCA2D5}"/>
               </a:ext>
             </a:extLst>
           </p:cNvPr>
@@ -6874,7 +6899,7 @@
           <p:cNvPr id="5" name="">
             <a:extLst xmlns:a="http://schemas.openxmlformats.org/drawingml/2006/main">
               <a:ext uri="{FF2B5EF4-FFF2-40B4-BE49-F238E27FC236}">
-                <a16:creationId xmlns:a16="http://schemas.microsoft.com/office/drawing/2014/main" id="{5B7ECDAD-29F1-472B-A72A-C474514B3E33}"/>
+                <a16:creationId xmlns:a16="http://schemas.microsoft.com/office/drawing/2014/main" id="{389D5CF2-33EC-4EA4-975C-59A088241E75}"/>
               </a:ext>
             </a:extLst>
           </p:cNvPr>
@@ -6938,7 +6963,7 @@
         </p:xfrm>
         <a:graphic xmlns:a="http://schemas.openxmlformats.org/drawingml/2006/main">
           <a:graphicData uri="http://schemas.openxmlformats.org/drawingml/2006/chart">
-            <c:chart xmlns:r="http://schemas.openxmlformats.org/officeDocument/2006/relationships" xmlns:c="http://schemas.openxmlformats.org/drawingml/2006/chart" r:id="R084d955eb4544d31"/>
+            <c:chart xmlns:r="http://schemas.openxmlformats.org/officeDocument/2006/relationships" xmlns:c="http://schemas.openxmlformats.org/drawingml/2006/chart" r:id="R0812704257764b22"/>
           </a:graphicData>
         </a:graphic>
       </p:graphicFrame>
@@ -6947,7 +6972,7 @@
           <p:cNvPr id="7" name="">
             <a:extLst xmlns:a="http://schemas.openxmlformats.org/drawingml/2006/main">
               <a:ext uri="{FF2B5EF4-FFF2-40B4-BE49-F238E27FC236}">
-                <a16:creationId xmlns:a16="http://schemas.microsoft.com/office/drawing/2014/main" id="{ED39EC02-9F59-4905-A00F-721B0D2BCD04}"/>
+                <a16:creationId xmlns:a16="http://schemas.microsoft.com/office/drawing/2014/main" id="{2CB172E5-EEA0-4F03-8A83-CBD7E9C668CB}"/>
               </a:ext>
             </a:extLst>
           </p:cNvPr>
@@ -7004,7 +7029,7 @@
           <p:cNvPr id="8" name="">
             <a:extLst xmlns:a="http://schemas.openxmlformats.org/drawingml/2006/main">
               <a:ext uri="{FF2B5EF4-FFF2-40B4-BE49-F238E27FC236}">
-                <a16:creationId xmlns:a16="http://schemas.microsoft.com/office/drawing/2014/main" id="{B8C973D4-225A-4B41-AB65-C4658A1C8CF3}"/>
+                <a16:creationId xmlns:a16="http://schemas.microsoft.com/office/drawing/2014/main" id="{99A402B1-276C-4F6C-9E76-B8D8F6F2DD9B}"/>
               </a:ext>
             </a:extLst>
           </p:cNvPr>
@@ -7034,7 +7059,7 @@
           <p:cNvPr id="9" name="">
             <a:extLst xmlns:a="http://schemas.openxmlformats.org/drawingml/2006/main">
               <a:ext uri="{FF2B5EF4-FFF2-40B4-BE49-F238E27FC236}">
-                <a16:creationId xmlns:a16="http://schemas.microsoft.com/office/drawing/2014/main" id="{0473EFFC-C2DF-4B22-9A4B-F042FE76C2F6}"/>
+                <a16:creationId xmlns:a16="http://schemas.microsoft.com/office/drawing/2014/main" id="{81F69A18-76A6-4B5E-8BD7-0974253F7B40}"/>
               </a:ext>
             </a:extLst>
           </p:cNvPr>
@@ -7091,7 +7116,7 @@
           <p:cNvPr id="10" name="">
             <a:extLst xmlns:a="http://schemas.openxmlformats.org/drawingml/2006/main">
               <a:ext uri="{FF2B5EF4-FFF2-40B4-BE49-F238E27FC236}">
-                <a16:creationId xmlns:a16="http://schemas.microsoft.com/office/drawing/2014/main" id="{281412E3-D887-4A08-BE5E-DF94FB1BCCDD}"/>
+                <a16:creationId xmlns:a16="http://schemas.microsoft.com/office/drawing/2014/main" id="{F1DEC269-C72C-4E1D-8172-544EBEF5AD5A}"/>
               </a:ext>
             </a:extLst>
           </p:cNvPr>
@@ -7171,7 +7196,7 @@
           <p:cNvPr id="11" name="">
             <a:extLst xmlns:a="http://schemas.openxmlformats.org/drawingml/2006/main">
               <a:ext uri="{FF2B5EF4-FFF2-40B4-BE49-F238E27FC236}">
-                <a16:creationId xmlns:a16="http://schemas.microsoft.com/office/drawing/2014/main" id="{7FB5A647-C512-4E67-89E4-258B0997971B}"/>
+                <a16:creationId xmlns:a16="http://schemas.microsoft.com/office/drawing/2014/main" id="{112E6BDC-DFA0-489C-B0E2-AB3D83CB8AB1}"/>
               </a:ext>
             </a:extLst>
           </p:cNvPr>
@@ -7201,7 +7226,7 @@
           <p:cNvPr id="12" name="">
             <a:extLst xmlns:a="http://schemas.openxmlformats.org/drawingml/2006/main">
               <a:ext uri="{FF2B5EF4-FFF2-40B4-BE49-F238E27FC236}">
-                <a16:creationId xmlns:a16="http://schemas.microsoft.com/office/drawing/2014/main" id="{8F497CD5-36E0-4EFF-86A8-65031C5EAB43}"/>
+                <a16:creationId xmlns:a16="http://schemas.microsoft.com/office/drawing/2014/main" id="{52B8AC20-C4A3-4E8D-B6F8-C99555FFCBE2}"/>
               </a:ext>
             </a:extLst>
           </p:cNvPr>
@@ -7281,7 +7306,7 @@
           <p:cNvPr id="13" name="">
             <a:extLst xmlns:a="http://schemas.openxmlformats.org/drawingml/2006/main">
               <a:ext uri="{FF2B5EF4-FFF2-40B4-BE49-F238E27FC236}">
-                <a16:creationId xmlns:a16="http://schemas.microsoft.com/office/drawing/2014/main" id="{83FCC845-1D02-456B-99F4-C3234AFF44A8}"/>
+                <a16:creationId xmlns:a16="http://schemas.microsoft.com/office/drawing/2014/main" id="{E9E20375-D43C-40EF-8D7E-9A2484DC2BE4}"/>
               </a:ext>
             </a:extLst>
           </p:cNvPr>
@@ -7336,7 +7361,7 @@
     </p:spTree>
     <p:extLst>
       <p:ext uri="{BB962C8B-B14F-4D97-AF65-F5344CB8AC3E}">
-        <p14:creationId xmlns:p14="http://schemas.microsoft.com/office/powerpoint/2010/main" val="1522190998"/>
+        <p14:creationId xmlns:p14="http://schemas.microsoft.com/office/powerpoint/2010/main" val="944463669"/>
       </p:ext>
     </p:extLst>
   </p:cSld>
@@ -7367,7 +7392,7 @@
           <p:cNvPr id="14" name="">
             <a:extLst xmlns:a="http://schemas.openxmlformats.org/drawingml/2006/main">
               <a:ext uri="{FF2B5EF4-FFF2-40B4-BE49-F238E27FC236}">
-                <a16:creationId xmlns:a16="http://schemas.microsoft.com/office/drawing/2014/main" id="{C58A8406-B5B0-4E99-BE6B-F41D4E64539F}"/>
+                <a16:creationId xmlns:a16="http://schemas.microsoft.com/office/drawing/2014/main" id="{235D0633-D6BC-4440-BC8B-8FD00AC5A35F}"/>
               </a:ext>
             </a:extLst>
           </p:cNvPr>
@@ -7424,7 +7449,7 @@
           <p:cNvPr id="2" name="">
             <a:extLst xmlns:a="http://schemas.openxmlformats.org/drawingml/2006/main">
               <a:ext uri="{FF2B5EF4-FFF2-40B4-BE49-F238E27FC236}">
-                <a16:creationId xmlns:a16="http://schemas.microsoft.com/office/drawing/2014/main" id="{C6CF7A76-7E81-4146-BCF6-6ABA63EE02EE}"/>
+                <a16:creationId xmlns:a16="http://schemas.microsoft.com/office/drawing/2014/main" id="{A1EB80B1-F67F-4910-A4F5-F02BCAA288DD}"/>
               </a:ext>
             </a:extLst>
           </p:cNvPr>
@@ -7454,7 +7479,7 @@
           <p:cNvPr id="3" name="">
             <a:extLst xmlns:a="http://schemas.openxmlformats.org/drawingml/2006/main">
               <a:ext uri="{FF2B5EF4-FFF2-40B4-BE49-F238E27FC236}">
-                <a16:creationId xmlns:a16="http://schemas.microsoft.com/office/drawing/2014/main" id="{32B0A4EA-8112-4FF3-918A-E5D50DEE6AA7}"/>
+                <a16:creationId xmlns:a16="http://schemas.microsoft.com/office/drawing/2014/main" id="{ED22B19F-80B1-4AC6-9586-96EC20D6CA59}"/>
               </a:ext>
             </a:extLst>
           </p:cNvPr>
@@ -7511,7 +7536,7 @@
           <p:cNvPr id="4" name="">
             <a:extLst xmlns:a="http://schemas.openxmlformats.org/drawingml/2006/main">
               <a:ext uri="{FF2B5EF4-FFF2-40B4-BE49-F238E27FC236}">
-                <a16:creationId xmlns:a16="http://schemas.microsoft.com/office/drawing/2014/main" id="{E018E243-5C5D-4EBD-B5CB-01DF6F6E0732}"/>
+                <a16:creationId xmlns:a16="http://schemas.microsoft.com/office/drawing/2014/main" id="{B59C7438-8D29-44CC-826B-39CBB71483B4}"/>
               </a:ext>
             </a:extLst>
           </p:cNvPr>
@@ -7568,7 +7593,7 @@
           <p:cNvPr id="5" name="">
             <a:extLst xmlns:a="http://schemas.openxmlformats.org/drawingml/2006/main">
               <a:ext uri="{FF2B5EF4-FFF2-40B4-BE49-F238E27FC236}">
-                <a16:creationId xmlns:a16="http://schemas.microsoft.com/office/drawing/2014/main" id="{B50A5917-C18E-4E09-9B3B-81508F7C336F}"/>
+                <a16:creationId xmlns:a16="http://schemas.microsoft.com/office/drawing/2014/main" id="{5739281B-B9F7-4F81-BC7D-FFF40132A127}"/>
               </a:ext>
             </a:extLst>
           </p:cNvPr>
@@ -7632,7 +7657,7 @@
         </p:xfrm>
         <a:graphic xmlns:a="http://schemas.openxmlformats.org/drawingml/2006/main">
           <a:graphicData uri="http://schemas.openxmlformats.org/drawingml/2006/chart">
-            <c:chart xmlns:r="http://schemas.openxmlformats.org/officeDocument/2006/relationships" xmlns:c="http://schemas.openxmlformats.org/drawingml/2006/chart" r:id="R9cbb31f594634d46"/>
+            <c:chart xmlns:r="http://schemas.openxmlformats.org/officeDocument/2006/relationships" xmlns:c="http://schemas.openxmlformats.org/drawingml/2006/chart" r:id="R86980e3acb5b4595"/>
           </a:graphicData>
         </a:graphic>
       </p:graphicFrame>
@@ -7641,7 +7666,7 @@
           <p:cNvPr id="7" name="">
             <a:extLst xmlns:a="http://schemas.openxmlformats.org/drawingml/2006/main">
               <a:ext uri="{FF2B5EF4-FFF2-40B4-BE49-F238E27FC236}">
-                <a16:creationId xmlns:a16="http://schemas.microsoft.com/office/drawing/2014/main" id="{15B09B2F-E2DC-4125-AA08-7AC7057656CA}"/>
+                <a16:creationId xmlns:a16="http://schemas.microsoft.com/office/drawing/2014/main" id="{422CC7F2-BA2D-4345-B8D8-F28CCC1115D1}"/>
               </a:ext>
             </a:extLst>
           </p:cNvPr>
@@ -7698,7 +7723,7 @@
           <p:cNvPr id="8" name="">
             <a:extLst xmlns:a="http://schemas.openxmlformats.org/drawingml/2006/main">
               <a:ext uri="{FF2B5EF4-FFF2-40B4-BE49-F238E27FC236}">
-                <a16:creationId xmlns:a16="http://schemas.microsoft.com/office/drawing/2014/main" id="{3DBD6285-817B-42C6-BF97-AA87B1D989F7}"/>
+                <a16:creationId xmlns:a16="http://schemas.microsoft.com/office/drawing/2014/main" id="{2AD0B1AE-377E-4113-A71A-D16BCDD84125}"/>
               </a:ext>
             </a:extLst>
           </p:cNvPr>
@@ -7728,7 +7753,7 @@
           <p:cNvPr id="9" name="">
             <a:extLst xmlns:a="http://schemas.openxmlformats.org/drawingml/2006/main">
               <a:ext uri="{FF2B5EF4-FFF2-40B4-BE49-F238E27FC236}">
-                <a16:creationId xmlns:a16="http://schemas.microsoft.com/office/drawing/2014/main" id="{26BD9CD4-CA44-4A88-B61E-FEA766C9CD29}"/>
+                <a16:creationId xmlns:a16="http://schemas.microsoft.com/office/drawing/2014/main" id="{75AEDFE7-B4E3-4F70-988E-CB5D40A50C74}"/>
               </a:ext>
             </a:extLst>
           </p:cNvPr>
@@ -7785,7 +7810,7 @@
           <p:cNvPr id="10" name="">
             <a:extLst xmlns:a="http://schemas.openxmlformats.org/drawingml/2006/main">
               <a:ext uri="{FF2B5EF4-FFF2-40B4-BE49-F238E27FC236}">
-                <a16:creationId xmlns:a16="http://schemas.microsoft.com/office/drawing/2014/main" id="{32FB10AE-0128-49F6-9924-EF44CF146484}"/>
+                <a16:creationId xmlns:a16="http://schemas.microsoft.com/office/drawing/2014/main" id="{9ACE69FB-D66E-4CE1-A24C-489D38794FEB}"/>
               </a:ext>
             </a:extLst>
           </p:cNvPr>
@@ -7865,7 +7890,7 @@
           <p:cNvPr id="11" name="">
             <a:extLst xmlns:a="http://schemas.openxmlformats.org/drawingml/2006/main">
               <a:ext uri="{FF2B5EF4-FFF2-40B4-BE49-F238E27FC236}">
-                <a16:creationId xmlns:a16="http://schemas.microsoft.com/office/drawing/2014/main" id="{CD8131FA-7B71-4D0F-8127-BD93E1FCAA51}"/>
+                <a16:creationId xmlns:a16="http://schemas.microsoft.com/office/drawing/2014/main" id="{8635A8D7-8EBB-4546-BBFC-82078655165F}"/>
               </a:ext>
             </a:extLst>
           </p:cNvPr>
@@ -7895,7 +7920,7 @@
           <p:cNvPr id="12" name="">
             <a:extLst xmlns:a="http://schemas.openxmlformats.org/drawingml/2006/main">
               <a:ext uri="{FF2B5EF4-FFF2-40B4-BE49-F238E27FC236}">
-                <a16:creationId xmlns:a16="http://schemas.microsoft.com/office/drawing/2014/main" id="{9C3792BC-BD10-46ED-A5E6-7EA9F1D287B6}"/>
+                <a16:creationId xmlns:a16="http://schemas.microsoft.com/office/drawing/2014/main" id="{59C4CBE9-CC95-4A60-9523-83DBF2E1E8C7}"/>
               </a:ext>
             </a:extLst>
           </p:cNvPr>
@@ -7952,7 +7977,7 @@
           <p:cNvPr id="13" name="">
             <a:extLst xmlns:a="http://schemas.openxmlformats.org/drawingml/2006/main">
               <a:ext uri="{FF2B5EF4-FFF2-40B4-BE49-F238E27FC236}">
-                <a16:creationId xmlns:a16="http://schemas.microsoft.com/office/drawing/2014/main" id="{F4CF21FA-E284-461D-AD0F-0CA3A3569C35}"/>
+                <a16:creationId xmlns:a16="http://schemas.microsoft.com/office/drawing/2014/main" id="{A92F4223-7BEE-4C03-A3BC-36AF790EEA80}"/>
               </a:ext>
             </a:extLst>
           </p:cNvPr>
@@ -8007,7 +8032,7 @@
     </p:spTree>
     <p:extLst>
       <p:ext uri="{BB962C8B-B14F-4D97-AF65-F5344CB8AC3E}">
-        <p14:creationId xmlns:p14="http://schemas.microsoft.com/office/powerpoint/2010/main" val="575367561"/>
+        <p14:creationId xmlns:p14="http://schemas.microsoft.com/office/powerpoint/2010/main" val="480517653"/>
       </p:ext>
     </p:extLst>
   </p:cSld>
@@ -8038,7 +8063,7 @@
           <p:cNvPr id="20" name="">
             <a:extLst xmlns:a="http://schemas.openxmlformats.org/drawingml/2006/main">
               <a:ext uri="{FF2B5EF4-FFF2-40B4-BE49-F238E27FC236}">
-                <a16:creationId xmlns:a16="http://schemas.microsoft.com/office/drawing/2014/main" id="{108F82B7-256C-4A58-98EC-A9AC0B2F890C}"/>
+                <a16:creationId xmlns:a16="http://schemas.microsoft.com/office/drawing/2014/main" id="{F5491690-CD99-4E93-8AA5-587218284CFB}"/>
               </a:ext>
             </a:extLst>
           </p:cNvPr>
@@ -8095,7 +8120,7 @@
           <p:cNvPr id="2" name="">
             <a:extLst xmlns:a="http://schemas.openxmlformats.org/drawingml/2006/main">
               <a:ext uri="{FF2B5EF4-FFF2-40B4-BE49-F238E27FC236}">
-                <a16:creationId xmlns:a16="http://schemas.microsoft.com/office/drawing/2014/main" id="{186CFD77-A83D-4C26-9024-32BEB6899643}"/>
+                <a16:creationId xmlns:a16="http://schemas.microsoft.com/office/drawing/2014/main" id="{8E8FA838-42FC-4DC7-ACB0-801DCEDFE70A}"/>
               </a:ext>
             </a:extLst>
           </p:cNvPr>
@@ -8125,7 +8150,7 @@
           <p:cNvPr id="3" name="">
             <a:extLst xmlns:a="http://schemas.openxmlformats.org/drawingml/2006/main">
               <a:ext uri="{FF2B5EF4-FFF2-40B4-BE49-F238E27FC236}">
-                <a16:creationId xmlns:a16="http://schemas.microsoft.com/office/drawing/2014/main" id="{A4B4E75F-1AA1-41D3-9E39-76A94D738A00}"/>
+                <a16:creationId xmlns:a16="http://schemas.microsoft.com/office/drawing/2014/main" id="{6C15CAF1-B543-4C29-BB1B-8E763DBF02EB}"/>
               </a:ext>
             </a:extLst>
           </p:cNvPr>
@@ -8182,7 +8207,7 @@
           <p:cNvPr id="4" name="">
             <a:extLst xmlns:a="http://schemas.openxmlformats.org/drawingml/2006/main">
               <a:ext uri="{FF2B5EF4-FFF2-40B4-BE49-F238E27FC236}">
-                <a16:creationId xmlns:a16="http://schemas.microsoft.com/office/drawing/2014/main" id="{930222B9-5089-4435-8506-29324AF29627}"/>
+                <a16:creationId xmlns:a16="http://schemas.microsoft.com/office/drawing/2014/main" id="{61D0FC07-3D63-4DB8-BFFF-4FA7DD23E045}"/>
               </a:ext>
             </a:extLst>
           </p:cNvPr>
@@ -8239,7 +8264,7 @@
           <p:cNvPr id="5" name="">
             <a:extLst xmlns:a="http://schemas.openxmlformats.org/drawingml/2006/main">
               <a:ext uri="{FF2B5EF4-FFF2-40B4-BE49-F238E27FC236}">
-                <a16:creationId xmlns:a16="http://schemas.microsoft.com/office/drawing/2014/main" id="{D6560180-3243-430D-9C69-E73BE0C502BD}"/>
+                <a16:creationId xmlns:a16="http://schemas.microsoft.com/office/drawing/2014/main" id="{6B7F58E0-928F-4C73-A151-02928F7FD3A3}"/>
               </a:ext>
             </a:extLst>
           </p:cNvPr>
@@ -8296,7 +8321,7 @@
           <p:cNvPr id="6" name="">
             <a:extLst xmlns:a="http://schemas.openxmlformats.org/drawingml/2006/main">
               <a:ext uri="{FF2B5EF4-FFF2-40B4-BE49-F238E27FC236}">
-                <a16:creationId xmlns:a16="http://schemas.microsoft.com/office/drawing/2014/main" id="{9734A96F-8902-4FA0-B878-7FA231B81F18}"/>
+                <a16:creationId xmlns:a16="http://schemas.microsoft.com/office/drawing/2014/main" id="{10C3646E-16EF-4866-B05B-9E4A6CAFDBA0}"/>
               </a:ext>
             </a:extLst>
           </p:cNvPr>
@@ -8353,7 +8378,7 @@
           <p:cNvPr id="7" name="">
             <a:extLst xmlns:a="http://schemas.openxmlformats.org/drawingml/2006/main">
               <a:ext uri="{FF2B5EF4-FFF2-40B4-BE49-F238E27FC236}">
-                <a16:creationId xmlns:a16="http://schemas.microsoft.com/office/drawing/2014/main" id="{41664B7B-8BC5-41F4-A7BB-2AD2B8CDE8D9}"/>
+                <a16:creationId xmlns:a16="http://schemas.microsoft.com/office/drawing/2014/main" id="{CBDC32E0-28DD-47D8-BB48-50B0AADBFBC3}"/>
               </a:ext>
             </a:extLst>
           </p:cNvPr>
@@ -8383,7 +8408,7 @@
           <p:cNvPr id="8" name="">
             <a:extLst xmlns:a="http://schemas.openxmlformats.org/drawingml/2006/main">
               <a:ext uri="{FF2B5EF4-FFF2-40B4-BE49-F238E27FC236}">
-                <a16:creationId xmlns:a16="http://schemas.microsoft.com/office/drawing/2014/main" id="{4BF0E92A-746D-40E8-A08D-D38D933C8DA4}"/>
+                <a16:creationId xmlns:a16="http://schemas.microsoft.com/office/drawing/2014/main" id="{438A724F-92A3-417C-BFCD-3582E7BC2DD7}"/>
               </a:ext>
             </a:extLst>
           </p:cNvPr>
@@ -8463,7 +8488,7 @@
           <p:cNvPr id="9" name="">
             <a:extLst xmlns:a="http://schemas.openxmlformats.org/drawingml/2006/main">
               <a:ext uri="{FF2B5EF4-FFF2-40B4-BE49-F238E27FC236}">
-                <a16:creationId xmlns:a16="http://schemas.microsoft.com/office/drawing/2014/main" id="{17445E61-0E93-44B4-8462-17AFBCD03334}"/>
+                <a16:creationId xmlns:a16="http://schemas.microsoft.com/office/drawing/2014/main" id="{0634917E-7FA4-4E2A-B909-2EFAFF499CA3}"/>
               </a:ext>
             </a:extLst>
           </p:cNvPr>
@@ -8520,7 +8545,7 @@
           <p:cNvPr id="10" name="">
             <a:extLst xmlns:a="http://schemas.openxmlformats.org/drawingml/2006/main">
               <a:ext uri="{FF2B5EF4-FFF2-40B4-BE49-F238E27FC236}">
-                <a16:creationId xmlns:a16="http://schemas.microsoft.com/office/drawing/2014/main" id="{B66D7F65-CAA7-4EAE-9BA7-FAF7BF585EF1}"/>
+                <a16:creationId xmlns:a16="http://schemas.microsoft.com/office/drawing/2014/main" id="{6A8E5075-7000-4DE7-8F14-B70A6AD3F9F2}"/>
               </a:ext>
             </a:extLst>
           </p:cNvPr>
@@ -8550,7 +8575,7 @@
           <p:cNvPr id="11" name="">
             <a:extLst xmlns:a="http://schemas.openxmlformats.org/drawingml/2006/main">
               <a:ext uri="{FF2B5EF4-FFF2-40B4-BE49-F238E27FC236}">
-                <a16:creationId xmlns:a16="http://schemas.microsoft.com/office/drawing/2014/main" id="{B375B523-FD4B-4A54-A64E-4C45BB1AE05D}"/>
+                <a16:creationId xmlns:a16="http://schemas.microsoft.com/office/drawing/2014/main" id="{F7A0B658-FFFB-4A2D-A0A9-0D7BE4E6C80A}"/>
               </a:ext>
             </a:extLst>
           </p:cNvPr>
@@ -8620,7 +8645,7 @@
                 <a:ea typeface="Arial"/>
                 <a:cs typeface="Arial"/>
               </a:rPr>
-              <a:t>Improve gap filling and ranges. Add area water totals.</a:t>
+              <a:t>Train on real data. Improve gaps/ranges + area totals.</a:t>
             </a:r>
           </a:p>
         </p:txBody>
@@ -8630,7 +8655,7 @@
           <p:cNvPr id="12" name="">
             <a:extLst xmlns:a="http://schemas.openxmlformats.org/drawingml/2006/main">
               <a:ext uri="{FF2B5EF4-FFF2-40B4-BE49-F238E27FC236}">
-                <a16:creationId xmlns:a16="http://schemas.microsoft.com/office/drawing/2014/main" id="{08351AB9-AE66-4E05-8E50-07D3F2CBEEF8}"/>
+                <a16:creationId xmlns:a16="http://schemas.microsoft.com/office/drawing/2014/main" id="{B2BBD46F-390E-465C-BD6D-39CF876BFA9C}"/>
               </a:ext>
             </a:extLst>
           </p:cNvPr>
@@ -8687,7 +8712,7 @@
           <p:cNvPr id="13" name="">
             <a:extLst xmlns:a="http://schemas.openxmlformats.org/drawingml/2006/main">
               <a:ext uri="{FF2B5EF4-FFF2-40B4-BE49-F238E27FC236}">
-                <a16:creationId xmlns:a16="http://schemas.microsoft.com/office/drawing/2014/main" id="{F816227F-C3C1-416A-9AA4-684848A425AE}"/>
+                <a16:creationId xmlns:a16="http://schemas.microsoft.com/office/drawing/2014/main" id="{69AD2320-088A-463D-A23F-8B883B8159C0}"/>
               </a:ext>
             </a:extLst>
           </p:cNvPr>
@@ -8717,7 +8742,7 @@
           <p:cNvPr id="14" name="">
             <a:extLst xmlns:a="http://schemas.openxmlformats.org/drawingml/2006/main">
               <a:ext uri="{FF2B5EF4-FFF2-40B4-BE49-F238E27FC236}">
-                <a16:creationId xmlns:a16="http://schemas.microsoft.com/office/drawing/2014/main" id="{340F0F5D-8EE8-48F7-94FA-66F0B4E00E8C}"/>
+                <a16:creationId xmlns:a16="http://schemas.microsoft.com/office/drawing/2014/main" id="{3D744239-8E84-4299-94CC-5BD9D469FBCD}"/>
               </a:ext>
             </a:extLst>
           </p:cNvPr>
@@ -8797,7 +8822,7 @@
           <p:cNvPr id="15" name="">
             <a:extLst xmlns:a="http://schemas.openxmlformats.org/drawingml/2006/main">
               <a:ext uri="{FF2B5EF4-FFF2-40B4-BE49-F238E27FC236}">
-                <a16:creationId xmlns:a16="http://schemas.microsoft.com/office/drawing/2014/main" id="{AC7A5C0D-F57D-4617-B371-0CC2C3866413}"/>
+                <a16:creationId xmlns:a16="http://schemas.microsoft.com/office/drawing/2014/main" id="{2202D93B-C78B-4F98-AA30-74F4F30BFCBB}"/>
               </a:ext>
             </a:extLst>
           </p:cNvPr>
@@ -8854,7 +8879,7 @@
           <p:cNvPr id="16" name="">
             <a:extLst xmlns:a="http://schemas.openxmlformats.org/drawingml/2006/main">
               <a:ext uri="{FF2B5EF4-FFF2-40B4-BE49-F238E27FC236}">
-                <a16:creationId xmlns:a16="http://schemas.microsoft.com/office/drawing/2014/main" id="{7B2E4E81-F9D4-4963-9FD4-4B5D032A4EDB}"/>
+                <a16:creationId xmlns:a16="http://schemas.microsoft.com/office/drawing/2014/main" id="{311F9102-BE3F-42CC-BCE8-4606F61CABD7}"/>
               </a:ext>
             </a:extLst>
           </p:cNvPr>
@@ -8884,7 +8909,7 @@
           <p:cNvPr id="17" name="">
             <a:extLst xmlns:a="http://schemas.openxmlformats.org/drawingml/2006/main">
               <a:ext uri="{FF2B5EF4-FFF2-40B4-BE49-F238E27FC236}">
-                <a16:creationId xmlns:a16="http://schemas.microsoft.com/office/drawing/2014/main" id="{55D06CB0-4F80-463D-A4CF-B7A8880B76EA}"/>
+                <a16:creationId xmlns:a16="http://schemas.microsoft.com/office/drawing/2014/main" id="{21F84A38-ECC3-4421-99D6-9539FE392001}"/>
               </a:ext>
             </a:extLst>
           </p:cNvPr>
@@ -8941,7 +8966,7 @@
           <p:cNvPr id="18" name="">
             <a:extLst xmlns:a="http://schemas.openxmlformats.org/drawingml/2006/main">
               <a:ext uri="{FF2B5EF4-FFF2-40B4-BE49-F238E27FC236}">
-                <a16:creationId xmlns:a16="http://schemas.microsoft.com/office/drawing/2014/main" id="{250F68D8-09FA-442D-AA9B-7AC0B81937D6}"/>
+                <a16:creationId xmlns:a16="http://schemas.microsoft.com/office/drawing/2014/main" id="{69A7238C-9BF3-4D9F-8150-1F5CD4317BFF}"/>
               </a:ext>
             </a:extLst>
           </p:cNvPr>
@@ -8988,7 +9013,7 @@
                 <a:ea typeface="Arial"/>
                 <a:cs typeface="Arial"/>
               </a:rPr>
-              <a:t>Can we test effects on water reserves and rivers in a new area through the year?</a:t>
+              <a:t>Can training on real data predict effects on water reserves and rivers in a new area?</a:t>
             </a:r>
           </a:p>
         </p:txBody>
@@ -8998,7 +9023,7 @@
           <p:cNvPr id="19" name="">
             <a:extLst xmlns:a="http://schemas.openxmlformats.org/drawingml/2006/main">
               <a:ext uri="{FF2B5EF4-FFF2-40B4-BE49-F238E27FC236}">
-                <a16:creationId xmlns:a16="http://schemas.microsoft.com/office/drawing/2014/main" id="{DA37BF8E-8305-4C35-9550-FED7DC7A1E45}"/>
+                <a16:creationId xmlns:a16="http://schemas.microsoft.com/office/drawing/2014/main" id="{6322CEE3-DED0-4FB1-BF88-C8E54F8DF9AA}"/>
               </a:ext>
             </a:extLst>
           </p:cNvPr>
@@ -9099,7 +9124,7 @@
     </p:spTree>
     <p:extLst>
       <p:ext uri="{BB962C8B-B14F-4D97-AF65-F5344CB8AC3E}">
-        <p14:creationId xmlns:p14="http://schemas.microsoft.com/office/powerpoint/2010/main" val="1816138024"/>
+        <p14:creationId xmlns:p14="http://schemas.microsoft.com/office/powerpoint/2010/main" val="1220705751"/>
       </p:ext>
     </p:extLst>
   </p:cSld>
@@ -9107,9 +9132,9 @@
 </file>
 
 <file path=ppt/theme/theme1.xml><?xml version="1.0" encoding="utf-8"?>
-<a:theme xmlns:a="http://schemas.openxmlformats.org/drawingml/2006/main" name="ChatGPT">
+<a:theme xmlns:a="http://schemas.openxmlformats.org/drawingml/2006/main" name="ECOllateral">
   <a:themeElements>
-    <a:clrScheme name="ChatGPT">
+    <a:clrScheme name="ECOllateral">
       <a:dk1>
         <a:srgbClr val="000000"/>
       </a:dk1>
@@ -9159,7 +9184,7 @@
         <a:cs typeface="Calibri"/>
       </a:minorFont>
     </a:fontScheme>
-    <a:fmtScheme name="ChatGPT">
+    <a:fmtScheme name="ECOllateral">
       <a:fillStyleLst>
         <a:solidFill>
           <a:schemeClr val="phClr"/>

</xml_diff>